<commit_message>
Sync updated literature PPT; stop publishing .workbuddy memory (local only)
</commit_message>
<xml_diff>
--- a/week3/凌润林第三周文献汇报.pptx
+++ b/week3/凌润林第三周文献汇报.pptx
@@ -5,15 +5,16 @@
     <p:sldMasterId id="2147483648" r:id="rId1"/>
   </p:sldMasterIdLst>
   <p:notesMasterIdLst>
-    <p:notesMasterId r:id="rId9"/>
+    <p:notesMasterId r:id="rId10"/>
   </p:notesMasterIdLst>
   <p:sldIdLst>
     <p:sldId id="256" r:id="rId3"/>
     <p:sldId id="257" r:id="rId4"/>
     <p:sldId id="258" r:id="rId5"/>
     <p:sldId id="259" r:id="rId6"/>
-    <p:sldId id="260" r:id="rId7"/>
-    <p:sldId id="261" r:id="rId8"/>
+    <p:sldId id="262" r:id="rId7"/>
+    <p:sldId id="260" r:id="rId8"/>
+    <p:sldId id="261" r:id="rId9"/>
   </p:sldIdLst>
   <p:sldSz cx="12192000" cy="6858000"/>
   <p:notesSz cx="6858000" cy="12192000"/>
@@ -2184,7 +2185,11 @@
         <p:nvSpPr>
           <p:cNvPr id="37" name="圆角矩形 36"/>
           <p:cNvSpPr/>
-          <p:nvPr/>
+          <p:nvPr>
+            <p:custDataLst>
+              <p:tags r:id="rId1"/>
+            </p:custDataLst>
+          </p:nvPr>
         </p:nvSpPr>
         <p:spPr>
           <a:xfrm>
@@ -2215,7 +2220,11 @@
         <p:nvSpPr>
           <p:cNvPr id="38" name="文本框 37" descr="{&quot;isTemplate&quot;:true,&quot;type&quot;:&quot;text&quot;}"/>
           <p:cNvSpPr txBox="1"/>
-          <p:nvPr/>
+          <p:nvPr>
+            <p:custDataLst>
+              <p:tags r:id="rId2"/>
+            </p:custDataLst>
+          </p:nvPr>
         </p:nvSpPr>
         <p:spPr>
           <a:xfrm>
@@ -2258,7 +2267,11 @@
         <p:nvSpPr>
           <p:cNvPr id="39" name="文本框 38" descr="{&quot;isTemplate&quot;:true,&quot;type&quot;:&quot;text&quot;}"/>
           <p:cNvSpPr txBox="1"/>
-          <p:nvPr/>
+          <p:nvPr>
+            <p:custDataLst>
+              <p:tags r:id="rId3"/>
+            </p:custDataLst>
+          </p:nvPr>
         </p:nvSpPr>
         <p:spPr>
           <a:xfrm>
@@ -2301,7 +2314,11 @@
         <p:nvSpPr>
           <p:cNvPr id="40" name="圆角矩形 39"/>
           <p:cNvSpPr/>
-          <p:nvPr/>
+          <p:nvPr>
+            <p:custDataLst>
+              <p:tags r:id="rId4"/>
+            </p:custDataLst>
+          </p:nvPr>
         </p:nvSpPr>
         <p:spPr>
           <a:xfrm>
@@ -2332,7 +2349,11 @@
         <p:nvSpPr>
           <p:cNvPr id="41" name="文本框 40" descr="{&quot;isTemplate&quot;:true,&quot;type&quot;:&quot;text&quot;}"/>
           <p:cNvSpPr txBox="1"/>
-          <p:nvPr/>
+          <p:nvPr>
+            <p:custDataLst>
+              <p:tags r:id="rId5"/>
+            </p:custDataLst>
+          </p:nvPr>
         </p:nvSpPr>
         <p:spPr>
           <a:xfrm>
@@ -2375,7 +2396,11 @@
         <p:nvSpPr>
           <p:cNvPr id="42" name="文本框 41" descr="{&quot;isTemplate&quot;:true,&quot;type&quot;:&quot;text&quot;}"/>
           <p:cNvSpPr txBox="1"/>
-          <p:nvPr/>
+          <p:nvPr>
+            <p:custDataLst>
+              <p:tags r:id="rId6"/>
+            </p:custDataLst>
+          </p:nvPr>
         </p:nvSpPr>
         <p:spPr>
           <a:xfrm>
@@ -2429,8 +2454,8 @@
                 <a:solidFill>
                   <a:srgbClr val="4A5568"/>
                 </a:solidFill>
-                <a:latin typeface="微软雅黑" charset="0"/>
-                <a:ea typeface="微软雅黑" charset="0"/>
+                <a:latin typeface="微软雅黑" panose="020B0503020204020204" charset="-122"/>
+                <a:ea typeface="微软雅黑" panose="020B0503020204020204" charset="-122"/>
               </a:rPr>
               <a:t>将其进行分类</a:t>
             </a:r>
@@ -2439,8 +2464,8 @@
                 <a:solidFill>
                   <a:srgbClr val="4A5568"/>
                 </a:solidFill>
-                <a:latin typeface="微软雅黑" charset="0"/>
-                <a:ea typeface="微软雅黑" charset="0"/>
+                <a:latin typeface="微软雅黑" panose="020B0503020204020204" charset="-122"/>
+                <a:ea typeface="微软雅黑" panose="020B0503020204020204" charset="-122"/>
               </a:rPr>
               <a:t>，找出与项目关联度高的方法</a:t>
             </a:r>
@@ -2468,7 +2493,11 @@
         <p:nvSpPr>
           <p:cNvPr id="43" name="圆角矩形 42"/>
           <p:cNvSpPr/>
-          <p:nvPr/>
+          <p:nvPr>
+            <p:custDataLst>
+              <p:tags r:id="rId7"/>
+            </p:custDataLst>
+          </p:nvPr>
         </p:nvSpPr>
         <p:spPr>
           <a:xfrm>
@@ -2499,7 +2528,11 @@
         <p:nvSpPr>
           <p:cNvPr id="44" name="文本框 43" descr="{&quot;isTemplate&quot;:true,&quot;type&quot;:&quot;text&quot;}"/>
           <p:cNvSpPr txBox="1"/>
-          <p:nvPr/>
+          <p:nvPr>
+            <p:custDataLst>
+              <p:tags r:id="rId8"/>
+            </p:custDataLst>
+          </p:nvPr>
         </p:nvSpPr>
         <p:spPr>
           <a:xfrm>
@@ -2543,7 +2576,11 @@
         <p:nvSpPr>
           <p:cNvPr id="45" name="文本框 44" descr="{&quot;isTemplate&quot;:true,&quot;type&quot;:&quot;text&quot;}"/>
           <p:cNvSpPr txBox="1"/>
-          <p:nvPr/>
+          <p:nvPr>
+            <p:custDataLst>
+              <p:tags r:id="rId9"/>
+            </p:custDataLst>
+          </p:nvPr>
         </p:nvSpPr>
         <p:spPr>
           <a:xfrm>
@@ -2825,165 +2862,6 @@
       </p:sp>
       <p:sp>
         <p:nvSpPr>
-          <p:cNvPr id="52" name="矩形 51"/>
-          <p:cNvSpPr/>
-          <p:nvPr/>
-        </p:nvSpPr>
-        <p:spPr>
-          <a:xfrm>
-            <a:off x="533400" y="5657850"/>
-            <a:ext cx="11277600" cy="676275"/>
-          </a:xfrm>
-          <a:prstGeom prst="rect">
-            <a:avLst/>
-          </a:prstGeom>
-          <a:solidFill>
-            <a:srgbClr val="F0F5FC"/>
-          </a:solidFill>
-        </p:spPr>
-        <p:txBody>
-          <a:bodyPr/>
-          <a:p/>
-        </p:txBody>
-      </p:sp>
-      <p:sp>
-        <p:nvSpPr>
-          <p:cNvPr id="53" name="任意多边形 52"/>
-          <p:cNvSpPr/>
-          <p:nvPr/>
-        </p:nvSpPr>
-        <p:spPr>
-          <a:xfrm>
-            <a:off x="495300" y="5657850"/>
-            <a:ext cx="11315700" cy="676275"/>
-          </a:xfrm>
-          <a:custGeom>
-            <a:avLst/>
-            <a:gdLst/>
-            <a:ahLst/>
-            <a:cxnLst/>
-            <a:pathLst>
-              <a:path w="1188" h="71">
-                <a:moveTo>
-                  <a:pt x="0" y="0"/>
-                </a:moveTo>
-                <a:lnTo>
-                  <a:pt x="4" y="0"/>
-                </a:lnTo>
-                <a:lnTo>
-                  <a:pt x="4" y="71"/>
-                </a:lnTo>
-                <a:lnTo>
-                  <a:pt x="0" y="71"/>
-                </a:lnTo>
-                <a:close/>
-              </a:path>
-            </a:pathLst>
-          </a:custGeom>
-          <a:solidFill>
-            <a:srgbClr val="1E4FA8"/>
-          </a:solidFill>
-        </p:spPr>
-        <p:txBody>
-          <a:bodyPr/>
-          <a:p/>
-        </p:txBody>
-      </p:sp>
-      <p:sp>
-        <p:nvSpPr>
-          <p:cNvPr id="54" name="文本框 53" descr="{&quot;isTemplate&quot;:true,&quot;type&quot;:&quot;text&quot;}"/>
-          <p:cNvSpPr txBox="1"/>
-          <p:nvPr/>
-        </p:nvSpPr>
-        <p:spPr>
-          <a:xfrm>
-            <a:off x="619125" y="5829350"/>
-            <a:ext cx="10896600" cy="333375"/>
-          </a:xfrm>
-          <a:prstGeom prst="rect">
-            <a:avLst/>
-          </a:prstGeom>
-        </p:spPr>
-        <p:txBody>
-          <a:bodyPr wrap="none" lIns="0" tIns="0" rIns="0" bIns="0"/>
-          <a:p>
-            <a:pPr>
-              <a:lnSpc>
-                <a:spcPct val="160000"/>
-              </a:lnSpc>
-            </a:pPr>
-            <a:r>
-              <a:rPr lang="zh-CN" sz="1350" b="1">
-                <a:solidFill>
-                  <a:srgbClr val="1E4FA8"/>
-                </a:solidFill>
-                <a:latin typeface="微软雅黑" panose="020B0503020204020204" charset="-122"/>
-                <a:ea typeface="微软雅黑" panose="020B0503020204020204" charset="-122"/>
-              </a:rPr>
-              <a:t>方法：</a:t>
-            </a:r>
-            <a:r>
-              <a:rPr lang="zh-CN" sz="1350">
-                <a:solidFill>
-                  <a:srgbClr val="1A2230"/>
-                </a:solidFill>
-                <a:latin typeface="微软雅黑" panose="020B0503020204020204" charset="-122"/>
-                <a:ea typeface="微软雅黑" panose="020B0503020204020204" charset="-122"/>
-              </a:rPr>
-              <a:t>以</a:t>
-            </a:r>
-            <a:r>
-              <a:rPr lang="en-US" sz="1350">
-                <a:solidFill>
-                  <a:srgbClr val="1A2230"/>
-                </a:solidFill>
-                <a:latin typeface="微软雅黑" panose="020B0503020204020204" charset="-122"/>
-                <a:ea typeface="微软雅黑" panose="020B0503020204020204" charset="-122"/>
-              </a:rPr>
-              <a:t>"</a:t>
-            </a:r>
-            <a:r>
-              <a:rPr lang="zh-CN" sz="1350">
-                <a:solidFill>
-                  <a:srgbClr val="1A2230"/>
-                </a:solidFill>
-                <a:latin typeface="微软雅黑" panose="020B0503020204020204" charset="-122"/>
-                <a:ea typeface="微软雅黑" panose="020B0503020204020204" charset="-122"/>
-              </a:rPr>
-              <a:t>问—读—写</a:t>
-            </a:r>
-            <a:r>
-              <a:rPr lang="en-US" sz="1350">
-                <a:solidFill>
-                  <a:srgbClr val="1A2230"/>
-                </a:solidFill>
-                <a:latin typeface="微软雅黑" panose="020B0503020204020204" charset="-122"/>
-                <a:ea typeface="微软雅黑" panose="020B0503020204020204" charset="-122"/>
-              </a:rPr>
-              <a:t>"</a:t>
-            </a:r>
-            <a:r>
-              <a:rPr lang="zh-CN" sz="1350">
-                <a:solidFill>
-                  <a:srgbClr val="1A2230"/>
-                </a:solidFill>
-                <a:latin typeface="微软雅黑" panose="020B0503020204020204" charset="-122"/>
-                <a:ea typeface="微软雅黑" panose="020B0503020204020204" charset="-122"/>
-              </a:rPr>
-              <a:t>小循环替代一次性大调研，每周都能交付一份可复核的资料，降低方向跑偏风险。</a:t>
-            </a:r>
-            <a:endParaRPr lang="zh-CN" sz="1350">
-              <a:solidFill>
-                <a:srgbClr val="1A2230"/>
-              </a:solidFill>
-              <a:latin typeface="微软雅黑" panose="020B0503020204020204" charset="-122"/>
-              <a:ea typeface="微软雅黑" panose="020B0503020204020204" charset="-122"/>
-            </a:endParaRPr>
-          </a:p>
-        </p:txBody>
-      </p:sp>
-      <p:sp>
-        <p:nvSpPr>
           <p:cNvPr id="55" name="矩形 54"/>
           <p:cNvSpPr/>
           <p:nvPr/>
@@ -3109,7 +2987,11 @@
         <p:nvSpPr>
           <p:cNvPr id="58" name="任意多边形 57"/>
           <p:cNvSpPr/>
-          <p:nvPr/>
+          <p:nvPr>
+            <p:custDataLst>
+              <p:tags r:id="rId1"/>
+            </p:custDataLst>
+          </p:nvPr>
         </p:nvSpPr>
         <p:spPr>
           <a:xfrm>
@@ -3175,7 +3057,11 @@
         <p:nvSpPr>
           <p:cNvPr id="59" name="文本框 58" descr="{&quot;isTemplate&quot;:true,&quot;type&quot;:&quot;text&quot;}"/>
           <p:cNvSpPr txBox="1"/>
-          <p:nvPr/>
+          <p:nvPr>
+            <p:custDataLst>
+              <p:tags r:id="rId2"/>
+            </p:custDataLst>
+          </p:nvPr>
         </p:nvSpPr>
         <p:spPr>
           <a:xfrm>
@@ -3218,7 +3104,11 @@
         <p:nvSpPr>
           <p:cNvPr id="60" name="文本框 59" descr="{&quot;isTemplate&quot;:true,&quot;type&quot;:&quot;text&quot;}"/>
           <p:cNvSpPr txBox="1"/>
-          <p:nvPr/>
+          <p:nvPr>
+            <p:custDataLst>
+              <p:tags r:id="rId3"/>
+            </p:custDataLst>
+          </p:nvPr>
         </p:nvSpPr>
         <p:spPr>
           <a:xfrm>
@@ -3295,7 +3185,11 @@
         <p:nvSpPr>
           <p:cNvPr id="61" name="文本框 60" descr="{&quot;isTemplate&quot;:true,&quot;type&quot;:&quot;text&quot;}"/>
           <p:cNvSpPr txBox="1"/>
-          <p:nvPr/>
+          <p:nvPr>
+            <p:custDataLst>
+              <p:tags r:id="rId4"/>
+            </p:custDataLst>
+          </p:nvPr>
         </p:nvSpPr>
         <p:spPr>
           <a:xfrm>
@@ -3340,7 +3234,11 @@
         <p:nvSpPr>
           <p:cNvPr id="62" name="任意多边形 61"/>
           <p:cNvSpPr/>
-          <p:nvPr/>
+          <p:nvPr>
+            <p:custDataLst>
+              <p:tags r:id="rId5"/>
+            </p:custDataLst>
+          </p:nvPr>
         </p:nvSpPr>
         <p:spPr>
           <a:xfrm>
@@ -3406,7 +3304,11 @@
         <p:nvSpPr>
           <p:cNvPr id="63" name="文本框 62" descr="{&quot;isTemplate&quot;:true,&quot;type&quot;:&quot;text&quot;}"/>
           <p:cNvSpPr txBox="1"/>
-          <p:nvPr/>
+          <p:nvPr>
+            <p:custDataLst>
+              <p:tags r:id="rId6"/>
+            </p:custDataLst>
+          </p:nvPr>
         </p:nvSpPr>
         <p:spPr>
           <a:xfrm>
@@ -3449,7 +3351,11 @@
         <p:nvSpPr>
           <p:cNvPr id="64" name="文本框 63" descr="{&quot;isTemplate&quot;:true,&quot;type&quot;:&quot;text&quot;}"/>
           <p:cNvSpPr txBox="1"/>
-          <p:nvPr/>
+          <p:nvPr>
+            <p:custDataLst>
+              <p:tags r:id="rId7"/>
+            </p:custDataLst>
+          </p:nvPr>
         </p:nvSpPr>
         <p:spPr>
           <a:xfrm>
@@ -3483,8 +3389,8 @@
                 <a:solidFill>
                   <a:srgbClr val="0E3F8C"/>
                 </a:solidFill>
-                <a:latin typeface="微软雅黑" charset="0"/>
-                <a:ea typeface="微软雅黑" charset="0"/>
+                <a:latin typeface="微软雅黑" panose="020B0503020204020204" charset="-122"/>
+                <a:ea typeface="微软雅黑" panose="020B0503020204020204" charset="-122"/>
               </a:rPr>
               <a:t>从方法</a:t>
             </a:r>
@@ -3493,8 +3399,8 @@
                 <a:solidFill>
                   <a:srgbClr val="0E3F8C"/>
                 </a:solidFill>
-                <a:latin typeface="微软雅黑" charset="0"/>
-                <a:ea typeface="微软雅黑" charset="0"/>
+                <a:latin typeface="微软雅黑" panose="020B0503020204020204" charset="-122"/>
+                <a:ea typeface="微软雅黑" panose="020B0503020204020204" charset="-122"/>
               </a:rPr>
               <a:t>深度上</a:t>
             </a:r>
@@ -3502,8 +3408,8 @@
               <a:solidFill>
                 <a:srgbClr val="0E3F8C"/>
               </a:solidFill>
-              <a:latin typeface="微软雅黑" charset="0"/>
-              <a:ea typeface="微软雅黑" charset="0"/>
+              <a:latin typeface="微软雅黑" panose="020B0503020204020204" charset="-122"/>
+              <a:ea typeface="微软雅黑" panose="020B0503020204020204" charset="-122"/>
             </a:endParaRPr>
           </a:p>
           <a:p>
@@ -3517,14 +3423,14 @@
                 <a:solidFill>
                   <a:srgbClr val="0E3F8C"/>
                 </a:solidFill>
-                <a:latin typeface="微软雅黑" charset="0"/>
-                <a:ea typeface="微软雅黑" charset="0"/>
+                <a:latin typeface="微软雅黑" panose="020B0503020204020204" charset="-122"/>
+                <a:ea typeface="微软雅黑" panose="020B0503020204020204" charset="-122"/>
               </a:rPr>
               <a:t>建立系统认知</a:t>
             </a:r>
             <a:endParaRPr lang="zh-CN">
-              <a:latin typeface="微软雅黑" charset="0"/>
-              <a:ea typeface="微软雅黑" charset="0"/>
+              <a:latin typeface="微软雅黑" panose="020B0503020204020204" charset="-122"/>
+              <a:ea typeface="微软雅黑" panose="020B0503020204020204" charset="-122"/>
             </a:endParaRPr>
           </a:p>
         </p:txBody>
@@ -3533,12 +3439,16 @@
         <p:nvSpPr>
           <p:cNvPr id="65" name="文本框 64" descr="{&quot;isTemplate&quot;:true,&quot;type&quot;:&quot;text&quot;}"/>
           <p:cNvSpPr txBox="1"/>
-          <p:nvPr/>
-        </p:nvSpPr>
-        <p:spPr>
-          <a:xfrm>
-            <a:off x="4400550" y="4061159"/>
-            <a:ext cx="3390900" cy="666750"/>
+          <p:nvPr>
+            <p:custDataLst>
+              <p:tags r:id="rId8"/>
+            </p:custDataLst>
+          </p:nvPr>
+        </p:nvSpPr>
+        <p:spPr>
+          <a:xfrm>
+            <a:off x="4400550" y="4061460"/>
+            <a:ext cx="3394710" cy="981710"/>
           </a:xfrm>
           <a:prstGeom prst="rect">
             <a:avLst/>
@@ -3546,7 +3456,7 @@
         </p:spPr>
         <p:txBody>
           <a:bodyPr wrap="square" lIns="0" tIns="0" rIns="0" bIns="0">
-            <a:normAutofit/>
+            <a:normAutofit fontScale="90000"/>
           </a:bodyPr>
           <a:p>
             <a:pPr>
@@ -3562,7 +3472,7 @@
                 <a:latin typeface="微软雅黑" panose="020B0503020204020204" charset="-122"/>
                 <a:ea typeface="微软雅黑" panose="020B0503020204020204" charset="-122"/>
               </a:rPr>
-              <a:t>按三条路线检索、翻译、抽取，每轮收敛一个子方向。</a:t>
+              <a:t>从定义到评估指标，将数据模拟方法进行分类，并了解各类方法的实现范式，判断与项目的关联度和作用</a:t>
             </a:r>
             <a:endParaRPr lang="zh-CN" sz="1350">
               <a:solidFill>
@@ -3578,7 +3488,11 @@
         <p:nvSpPr>
           <p:cNvPr id="66" name="任意多边形 65"/>
           <p:cNvSpPr/>
-          <p:nvPr/>
+          <p:nvPr>
+            <p:custDataLst>
+              <p:tags r:id="rId9"/>
+            </p:custDataLst>
+          </p:nvPr>
         </p:nvSpPr>
         <p:spPr>
           <a:xfrm>
@@ -3644,7 +3558,11 @@
         <p:nvSpPr>
           <p:cNvPr id="67" name="文本框 66" descr="{&quot;isTemplate&quot;:true,&quot;type&quot;:&quot;text&quot;}"/>
           <p:cNvSpPr txBox="1"/>
-          <p:nvPr/>
+          <p:nvPr>
+            <p:custDataLst>
+              <p:tags r:id="rId10"/>
+            </p:custDataLst>
+          </p:nvPr>
         </p:nvSpPr>
         <p:spPr>
           <a:xfrm>
@@ -3687,7 +3605,11 @@
         <p:nvSpPr>
           <p:cNvPr id="68" name="文本框 67" descr="{&quot;isTemplate&quot;:true,&quot;type&quot;:&quot;text&quot;}"/>
           <p:cNvSpPr txBox="1"/>
-          <p:nvPr/>
+          <p:nvPr>
+            <p:custDataLst>
+              <p:tags r:id="rId11"/>
+            </p:custDataLst>
+          </p:nvPr>
         </p:nvSpPr>
         <p:spPr>
           <a:xfrm>
@@ -3751,12 +3673,16 @@
         <p:nvSpPr>
           <p:cNvPr id="69" name="文本框 68" descr="{&quot;isTemplate&quot;:true,&quot;type&quot;:&quot;text&quot;}"/>
           <p:cNvSpPr txBox="1"/>
-          <p:nvPr/>
-        </p:nvSpPr>
-        <p:spPr>
-          <a:xfrm>
-            <a:off x="8353425" y="4061159"/>
-            <a:ext cx="3381375" cy="666750"/>
+          <p:nvPr>
+            <p:custDataLst>
+              <p:tags r:id="rId12"/>
+            </p:custDataLst>
+          </p:nvPr>
+        </p:nvSpPr>
+        <p:spPr>
+          <a:xfrm>
+            <a:off x="8353425" y="4061460"/>
+            <a:ext cx="3293745" cy="1153795"/>
           </a:xfrm>
           <a:prstGeom prst="rect">
             <a:avLst/>
@@ -3780,7 +3706,7 @@
                 <a:latin typeface="微软雅黑" panose="020B0503020204020204" charset="-122"/>
                 <a:ea typeface="微软雅黑" panose="020B0503020204020204" charset="-122"/>
               </a:rPr>
-              <a:t>把结论整理为名词表、方法集与论文落位，形成资料。</a:t>
+              <a:t>回顾这周项目实践过程中给大模型的提示词、大模型的输出与最终成果，反思可以改进的地方，抽象出一套工作流，将成果进行开源</a:t>
             </a:r>
             <a:endParaRPr lang="zh-CN" sz="1350">
               <a:solidFill>
@@ -3796,7 +3722,11 @@
         <p:nvSpPr>
           <p:cNvPr id="70" name="矩形 69"/>
           <p:cNvSpPr/>
-          <p:nvPr/>
+          <p:nvPr>
+            <p:custDataLst>
+              <p:tags r:id="rId13"/>
+            </p:custDataLst>
+          </p:nvPr>
         </p:nvSpPr>
         <p:spPr>
           <a:xfrm>
@@ -3858,111 +3788,55 @@
           </a:p>
         </p:txBody>
       </p:sp>
-      <p:sp>
-        <p:nvSpPr>
-          <p:cNvPr id="74" name="圆角矩形 73"/>
-          <p:cNvSpPr/>
-          <p:nvPr>
-            <p:custDataLst>
-              <p:tags r:id="rId1"/>
-            </p:custDataLst>
-          </p:nvPr>
-        </p:nvSpPr>
-        <p:spPr>
-          <a:xfrm>
-            <a:off x="168943" y="1028700"/>
-            <a:ext cx="2644942" cy="1219200"/>
-          </a:xfrm>
-          <a:prstGeom prst="roundRect">
-            <a:avLst>
-              <a:gd name="adj" fmla="val 0"/>
-            </a:avLst>
-          </a:prstGeom>
-          <a:solidFill>
-            <a:srgbClr val="F0F5FC"/>
-          </a:solidFill>
-          <a:ln w="12700">
-            <a:solidFill>
-              <a:srgbClr val="D6DCE5"/>
-            </a:solidFill>
-            <a:prstDash val="solid"/>
-          </a:ln>
-        </p:spPr>
-        <p:txBody>
-          <a:bodyPr/>
-          <a:p/>
-        </p:txBody>
-      </p:sp>
-      <p:sp>
-        <p:nvSpPr>
-          <p:cNvPr id="2" name="圆角矩形 1"/>
-          <p:cNvSpPr/>
-          <p:nvPr>
-            <p:custDataLst>
-              <p:tags r:id="rId2"/>
-            </p:custDataLst>
-          </p:nvPr>
-        </p:nvSpPr>
-        <p:spPr>
-          <a:xfrm>
-            <a:off x="4230604" y="1028700"/>
-            <a:ext cx="2644942" cy="1219200"/>
-          </a:xfrm>
-          <a:prstGeom prst="roundRect">
-            <a:avLst>
-              <a:gd name="adj" fmla="val 0"/>
-            </a:avLst>
-          </a:prstGeom>
-          <a:solidFill>
-            <a:srgbClr val="F0F5FC"/>
-          </a:solidFill>
-          <a:ln w="12700">
-            <a:solidFill>
-              <a:srgbClr val="D6DCE5"/>
-            </a:solidFill>
-            <a:prstDash val="solid"/>
-          </a:ln>
-        </p:spPr>
-        <p:txBody>
-          <a:bodyPr/>
-          <a:p/>
-        </p:txBody>
-      </p:sp>
-      <p:sp>
-        <p:nvSpPr>
-          <p:cNvPr id="3" name="圆角矩形 2"/>
-          <p:cNvSpPr/>
-          <p:nvPr>
-            <p:custDataLst>
-              <p:tags r:id="rId3"/>
-            </p:custDataLst>
-          </p:nvPr>
-        </p:nvSpPr>
-        <p:spPr>
-          <a:xfrm>
-            <a:off x="8611101" y="1028700"/>
-            <a:ext cx="2644942" cy="1219200"/>
-          </a:xfrm>
-          <a:prstGeom prst="roundRect">
-            <a:avLst>
-              <a:gd name="adj" fmla="val 0"/>
-            </a:avLst>
-          </a:prstGeom>
-          <a:solidFill>
-            <a:srgbClr val="F0F5FC"/>
-          </a:solidFill>
-          <a:ln w="12700">
-            <a:solidFill>
-              <a:srgbClr val="D6DCE5"/>
-            </a:solidFill>
-            <a:prstDash val="solid"/>
-          </a:ln>
-        </p:spPr>
-        <p:txBody>
-          <a:bodyPr/>
-          <a:p/>
-        </p:txBody>
-      </p:sp>
+      <p:pic>
+        <p:nvPicPr>
+          <p:cNvPr id="1" name="图片 0"/>
+          <p:cNvPicPr>
+            <a:picLocks noChangeAspect="1"/>
+          </p:cNvPicPr>
+          <p:nvPr/>
+        </p:nvPicPr>
+        <p:blipFill>
+          <a:blip r:embed="rId14"/>
+          <a:srcRect l="19142" t="8744" r="20400" b="14989"/>
+          <a:stretch>
+            <a:fillRect/>
+          </a:stretch>
+        </p:blipFill>
+        <p:spPr>
+          <a:xfrm>
+            <a:off x="5340350" y="974090"/>
+            <a:ext cx="2454910" cy="1725930"/>
+          </a:xfrm>
+          <a:prstGeom prst="rect">
+            <a:avLst/>
+          </a:prstGeom>
+        </p:spPr>
+      </p:pic>
+      <p:pic>
+        <p:nvPicPr>
+          <p:cNvPr id="4" name="图片 3"/>
+          <p:cNvPicPr>
+            <a:picLocks noChangeAspect="1"/>
+          </p:cNvPicPr>
+          <p:nvPr/>
+        </p:nvPicPr>
+        <p:blipFill>
+          <a:blip r:embed="rId15"/>
+          <a:stretch>
+            <a:fillRect/>
+          </a:stretch>
+        </p:blipFill>
+        <p:spPr>
+          <a:xfrm>
+            <a:off x="9107170" y="1308100"/>
+            <a:ext cx="2940050" cy="1391920"/>
+          </a:xfrm>
+          <a:prstGeom prst="rect">
+            <a:avLst/>
+          </a:prstGeom>
+        </p:spPr>
+      </p:pic>
     </p:spTree>
   </p:cSld>
   <p:clrMapOvr>
@@ -4013,7 +3887,173 @@
       </p:sp>
       <p:sp>
         <p:nvSpPr>
-          <p:cNvPr id="74" name="圆角矩形 73"/>
+          <p:cNvPr id="99" name="矩形 98"/>
+          <p:cNvSpPr/>
+          <p:nvPr/>
+        </p:nvSpPr>
+        <p:spPr>
+          <a:xfrm>
+            <a:off x="0" y="0"/>
+            <a:ext cx="12192000" cy="838200"/>
+          </a:xfrm>
+          <a:prstGeom prst="rect">
+            <a:avLst/>
+          </a:prstGeom>
+          <a:solidFill>
+            <a:srgbClr val="0E3F8C"/>
+          </a:solidFill>
+        </p:spPr>
+        <p:txBody>
+          <a:bodyPr/>
+          <a:p/>
+        </p:txBody>
+      </p:sp>
+      <p:sp>
+        <p:nvSpPr>
+          <p:cNvPr id="100" name="文本框 99" descr="{&quot;isTemplate&quot;:true,&quot;type&quot;:&quot;text&quot;}"/>
+          <p:cNvSpPr txBox="1"/>
+          <p:nvPr/>
+        </p:nvSpPr>
+        <p:spPr>
+          <a:xfrm>
+            <a:off x="381000" y="266700"/>
+            <a:ext cx="1076325" cy="342900"/>
+          </a:xfrm>
+          <a:prstGeom prst="rect">
+            <a:avLst/>
+          </a:prstGeom>
+        </p:spPr>
+        <p:txBody>
+          <a:bodyPr wrap="none" lIns="0" tIns="0" rIns="0" bIns="0"/>
+          <a:p>
+            <a:pPr>
+              <a:lnSpc>
+                <a:spcPct val="100000"/>
+              </a:lnSpc>
+            </a:pPr>
+            <a:r>
+              <a:rPr lang="en-US" sz="2250" b="1">
+                <a:solidFill>
+                  <a:srgbClr val="FFFFFF"/>
+                </a:solidFill>
+                <a:latin typeface="微软雅黑" panose="020B0503020204020204" charset="-122"/>
+                <a:ea typeface="微软雅黑" panose="020B0503020204020204" charset="-122"/>
+              </a:rPr>
+              <a:t>R · </a:t>
+            </a:r>
+            <a:r>
+              <a:rPr lang="zh-CN" sz="2250" b="1">
+                <a:solidFill>
+                  <a:srgbClr val="FFFFFF"/>
+                </a:solidFill>
+                <a:latin typeface="微软雅黑" panose="020B0503020204020204" charset="-122"/>
+                <a:ea typeface="微软雅黑" panose="020B0503020204020204" charset="-122"/>
+              </a:rPr>
+              <a:t>结果</a:t>
+            </a:r>
+            <a:endParaRPr lang="zh-CN" sz="2250" b="1">
+              <a:solidFill>
+                <a:srgbClr val="FFFFFF"/>
+              </a:solidFill>
+              <a:latin typeface="微软雅黑" panose="020B0503020204020204" charset="-122"/>
+              <a:ea typeface="微软雅黑" panose="020B0503020204020204" charset="-122"/>
+            </a:endParaRPr>
+          </a:p>
+        </p:txBody>
+      </p:sp>
+      <p:sp>
+        <p:nvSpPr>
+          <p:cNvPr id="101" name="文本框 100" descr="{&quot;isTemplate&quot;:true,&quot;type&quot;:&quot;text&quot;}"/>
+          <p:cNvSpPr txBox="1"/>
+          <p:nvPr/>
+        </p:nvSpPr>
+        <p:spPr>
+          <a:xfrm>
+            <a:off x="10744200" y="304800"/>
+            <a:ext cx="1066800" cy="190500"/>
+          </a:xfrm>
+          <a:prstGeom prst="rect">
+            <a:avLst/>
+          </a:prstGeom>
+        </p:spPr>
+        <p:txBody>
+          <a:bodyPr wrap="none" lIns="0" tIns="0" rIns="0" bIns="0"/>
+          <a:p>
+            <a:pPr>
+              <a:lnSpc>
+                <a:spcPct val="100000"/>
+              </a:lnSpc>
+            </a:pPr>
+            <a:r>
+              <a:rPr lang="zh-CN" sz="1200">
+                <a:solidFill>
+                  <a:srgbClr val="FFFFFF">
+                    <a:alpha val="70000"/>
+                  </a:srgbClr>
+                </a:solidFill>
+                <a:latin typeface="微软雅黑" panose="020B0503020204020204" charset="-122"/>
+                <a:ea typeface="微软雅黑" panose="020B0503020204020204" charset="-122"/>
+              </a:rPr>
+              <a:t>结果怎么样</a:t>
+            </a:r>
+            <a:endParaRPr lang="zh-CN" sz="1200">
+              <a:solidFill>
+                <a:srgbClr val="FFFFFF">
+                  <a:alpha val="70000"/>
+                </a:srgbClr>
+              </a:solidFill>
+              <a:latin typeface="微软雅黑" panose="020B0503020204020204" charset="-122"/>
+              <a:ea typeface="微软雅黑" panose="020B0503020204020204" charset="-122"/>
+            </a:endParaRPr>
+          </a:p>
+        </p:txBody>
+      </p:sp>
+      <p:sp>
+        <p:nvSpPr>
+          <p:cNvPr id="102" name="文本框 101" descr="{&quot;isTemplate&quot;:true,&quot;type&quot;:&quot;text&quot;}"/>
+          <p:cNvSpPr txBox="1"/>
+          <p:nvPr/>
+        </p:nvSpPr>
+        <p:spPr>
+          <a:xfrm>
+            <a:off x="11353800" y="6524625"/>
+            <a:ext cx="457200" cy="161925"/>
+          </a:xfrm>
+          <a:prstGeom prst="rect">
+            <a:avLst/>
+          </a:prstGeom>
+        </p:spPr>
+        <p:txBody>
+          <a:bodyPr wrap="none" lIns="0" tIns="0" rIns="0" bIns="0"/>
+          <a:p>
+            <a:pPr>
+              <a:lnSpc>
+                <a:spcPct val="100000"/>
+              </a:lnSpc>
+            </a:pPr>
+            <a:r>
+              <a:rPr lang="en-US" sz="1050">
+                <a:solidFill>
+                  <a:srgbClr val="8B97A8"/>
+                </a:solidFill>
+                <a:latin typeface="微软雅黑" panose="020B0503020204020204" charset="-122"/>
+                <a:ea typeface="微软雅黑" panose="020B0503020204020204" charset="-122"/>
+              </a:rPr>
+              <a:t>05 / 06</a:t>
+            </a:r>
+            <a:endParaRPr lang="en-US" sz="1050">
+              <a:solidFill>
+                <a:srgbClr val="8B97A8"/>
+              </a:solidFill>
+              <a:latin typeface="微软雅黑" panose="020B0503020204020204" charset="-122"/>
+              <a:ea typeface="微软雅黑" panose="020B0503020204020204" charset="-122"/>
+            </a:endParaRPr>
+          </a:p>
+        </p:txBody>
+      </p:sp>
+      <p:sp>
+        <p:nvSpPr>
+          <p:cNvPr id="1" name="圆角矩形 0"/>
           <p:cNvSpPr/>
           <p:nvPr>
             <p:custDataLst>
@@ -4023,8 +4063,8 @@
         </p:nvSpPr>
         <p:spPr>
           <a:xfrm>
-            <a:off x="381000" y="2019300"/>
-            <a:ext cx="3686175" cy="1533525"/>
+            <a:off x="320040" y="3711575"/>
+            <a:ext cx="5347335" cy="2206625"/>
           </a:xfrm>
           <a:prstGeom prst="roundRect">
             <a:avLst>
@@ -4048,8 +4088,8 @@
       </p:sp>
       <p:sp>
         <p:nvSpPr>
-          <p:cNvPr id="75" name="文本框 74" descr="{&quot;isTemplate&quot;:true,&quot;type&quot;:&quot;text&quot;}"/>
-          <p:cNvSpPr txBox="1"/>
+          <p:cNvPr id="3" name="圆角矩形 2"/>
+          <p:cNvSpPr/>
           <p:nvPr>
             <p:custDataLst>
               <p:tags r:id="rId2"/>
@@ -4058,189 +4098,8 @@
         </p:nvSpPr>
         <p:spPr>
           <a:xfrm>
-            <a:off x="590550" y="2228850"/>
-            <a:ext cx="3267075" cy="257175"/>
-          </a:xfrm>
-          <a:prstGeom prst="rect">
-            <a:avLst/>
-          </a:prstGeom>
-        </p:spPr>
-        <p:txBody>
-          <a:bodyPr wrap="none" lIns="0" tIns="0" rIns="0" bIns="0"/>
-          <a:p>
-            <a:pPr>
-              <a:lnSpc>
-                <a:spcPct val="100000"/>
-              </a:lnSpc>
-            </a:pPr>
-            <a:r>
-              <a:rPr lang="zh-CN" sz="1650" b="1">
-                <a:solidFill>
-                  <a:srgbClr val="0E3F8C"/>
-                </a:solidFill>
-                <a:latin typeface="微软雅黑" panose="020B0503020204020204" charset="-122"/>
-                <a:ea typeface="微软雅黑" panose="020B0503020204020204" charset="-122"/>
-              </a:rPr>
-              <a:t>发现关联性论文</a:t>
-            </a:r>
-            <a:endParaRPr lang="zh-CN" sz="1650" b="1">
-              <a:solidFill>
-                <a:srgbClr val="0E3F8C"/>
-              </a:solidFill>
-              <a:latin typeface="微软雅黑" panose="020B0503020204020204" charset="-122"/>
-              <a:ea typeface="微软雅黑" panose="020B0503020204020204" charset="-122"/>
-            </a:endParaRPr>
-          </a:p>
-        </p:txBody>
-      </p:sp>
-      <p:sp>
-        <p:nvSpPr>
-          <p:cNvPr id="76" name="文本框 75" descr="{&quot;isTemplate&quot;:true,&quot;type&quot;:&quot;text&quot;}"/>
-          <p:cNvSpPr txBox="1"/>
-          <p:nvPr>
-            <p:custDataLst>
-              <p:tags r:id="rId3"/>
-            </p:custDataLst>
-          </p:nvPr>
-        </p:nvSpPr>
-        <p:spPr>
-          <a:xfrm>
-            <a:off x="590550" y="2562225"/>
-            <a:ext cx="3267075" cy="504825"/>
-          </a:xfrm>
-          <a:prstGeom prst="rect">
-            <a:avLst/>
-          </a:prstGeom>
-        </p:spPr>
-        <p:txBody>
-          <a:bodyPr wrap="none" lIns="0" tIns="0" rIns="0" bIns="0"/>
-          <a:p>
-            <a:pPr>
-              <a:lnSpc>
-                <a:spcPct val="100000"/>
-              </a:lnSpc>
-            </a:pPr>
-            <a:r>
-              <a:rPr lang="en-US" altLang="zh-CN" sz="3300" b="1">
-                <a:solidFill>
-                  <a:srgbClr val="1E4FA8"/>
-                </a:solidFill>
-                <a:latin typeface="微软雅黑" panose="020B0503020204020204" charset="-122"/>
-                <a:ea typeface="微软雅黑" panose="020B0503020204020204" charset="-122"/>
-              </a:rPr>
-              <a:t>25</a:t>
-            </a:r>
-            <a:r>
-              <a:rPr lang="zh-CN" altLang="en-US" sz="3300" b="1">
-                <a:solidFill>
-                  <a:srgbClr val="1E4FA8"/>
-                </a:solidFill>
-                <a:latin typeface="微软雅黑" panose="020B0503020204020204" charset="-122"/>
-                <a:ea typeface="微软雅黑" panose="020B0503020204020204" charset="-122"/>
-              </a:rPr>
-              <a:t>-</a:t>
-            </a:r>
-            <a:r>
-              <a:rPr lang="en-US" altLang="zh-CN" sz="3300" b="1">
-                <a:solidFill>
-                  <a:srgbClr val="1E4FA8"/>
-                </a:solidFill>
-                <a:latin typeface="微软雅黑" panose="020B0503020204020204" charset="-122"/>
-                <a:ea typeface="微软雅黑" panose="020B0503020204020204" charset="-122"/>
-              </a:rPr>
-              <a:t>2</a:t>
-            </a:r>
-            <a:endParaRPr lang="en-US" sz="3300" b="1">
-              <a:solidFill>
-                <a:srgbClr val="1E4FA8"/>
-              </a:solidFill>
-              <a:latin typeface="微软雅黑" panose="020B0503020204020204" charset="-122"/>
-              <a:ea typeface="微软雅黑" panose="020B0503020204020204" charset="-122"/>
-            </a:endParaRPr>
-          </a:p>
-        </p:txBody>
-      </p:sp>
-      <p:sp>
-        <p:nvSpPr>
-          <p:cNvPr id="77" name="文本框 76" descr="{&quot;isTemplate&quot;:true,&quot;type&quot;:&quot;text&quot;}"/>
-          <p:cNvSpPr txBox="1"/>
-          <p:nvPr>
-            <p:custDataLst>
-              <p:tags r:id="rId4"/>
-            </p:custDataLst>
-          </p:nvPr>
-        </p:nvSpPr>
-        <p:spPr>
-          <a:xfrm>
-            <a:off x="590550" y="3143250"/>
-            <a:ext cx="3267075" cy="200025"/>
-          </a:xfrm>
-          <a:prstGeom prst="rect">
-            <a:avLst/>
-          </a:prstGeom>
-        </p:spPr>
-        <p:txBody>
-          <a:bodyPr wrap="none" lIns="0" tIns="0" rIns="0" bIns="0"/>
-          <a:p>
-            <a:pPr>
-              <a:lnSpc>
-                <a:spcPct val="100000"/>
-              </a:lnSpc>
-            </a:pPr>
-            <a:r>
-              <a:rPr lang="zh-CN" altLang="en-US" sz="1275">
-                <a:solidFill>
-                  <a:srgbClr val="4A5568"/>
-                </a:solidFill>
-                <a:latin typeface="微软雅黑" panose="020B0503020204020204" charset="-122"/>
-                <a:ea typeface="微软雅黑" panose="020B0503020204020204" charset="-122"/>
-              </a:rPr>
-              <a:t>在</a:t>
-            </a:r>
-            <a:r>
-              <a:rPr lang="en-US" altLang="zh-CN" sz="1275">
-                <a:solidFill>
-                  <a:srgbClr val="4A5568"/>
-                </a:solidFill>
-                <a:latin typeface="微软雅黑" panose="020B0503020204020204" charset="-122"/>
-                <a:ea typeface="微软雅黑" panose="020B0503020204020204" charset="-122"/>
-              </a:rPr>
-              <a:t>25</a:t>
-            </a:r>
-            <a:r>
-              <a:rPr lang="zh-CN" altLang="en-US" sz="1275">
-                <a:solidFill>
-                  <a:srgbClr val="4A5568"/>
-                </a:solidFill>
-                <a:latin typeface="微软雅黑" panose="020B0503020204020204" charset="-122"/>
-                <a:ea typeface="微软雅黑" panose="020B0503020204020204" charset="-122"/>
-              </a:rPr>
-              <a:t>篇相关论文中，找到两篇相关度最高的论文</a:t>
-            </a:r>
-            <a:endParaRPr lang="zh-CN" sz="1275">
-              <a:solidFill>
-                <a:srgbClr val="4A5568"/>
-              </a:solidFill>
-              <a:latin typeface="微软雅黑" panose="020B0503020204020204" charset="-122"/>
-              <a:ea typeface="微软雅黑" panose="020B0503020204020204" charset="-122"/>
-            </a:endParaRPr>
-          </a:p>
-        </p:txBody>
-      </p:sp>
-      <p:sp>
-        <p:nvSpPr>
-          <p:cNvPr id="78" name="圆角矩形 77"/>
-          <p:cNvSpPr/>
-          <p:nvPr>
-            <p:custDataLst>
-              <p:tags r:id="rId5"/>
-            </p:custDataLst>
-          </p:nvPr>
-        </p:nvSpPr>
-        <p:spPr>
-          <a:xfrm>
-            <a:off x="4257675" y="2019300"/>
-            <a:ext cx="3676650" cy="1533525"/>
+            <a:off x="6055995" y="3711575"/>
+            <a:ext cx="5878830" cy="2197100"/>
           </a:xfrm>
           <a:prstGeom prst="roundRect">
             <a:avLst>
@@ -4264,7 +4123,168 @@
       </p:sp>
       <p:sp>
         <p:nvSpPr>
-          <p:cNvPr id="79" name="文本框 78" descr="{&quot;isTemplate&quot;:true,&quot;type&quot;:&quot;text&quot;}"/>
+          <p:cNvPr id="6" name="文本框 5" descr="{&quot;isTemplate&quot;:true,&quot;type&quot;:&quot;text&quot;}"/>
+          <p:cNvSpPr txBox="1"/>
+          <p:nvPr>
+            <p:custDataLst>
+              <p:tags r:id="rId3"/>
+            </p:custDataLst>
+          </p:nvPr>
+        </p:nvSpPr>
+        <p:spPr>
+          <a:xfrm>
+            <a:off x="433705" y="3328670"/>
+            <a:ext cx="3322955" cy="505460"/>
+          </a:xfrm>
+          <a:prstGeom prst="rect">
+            <a:avLst/>
+          </a:prstGeom>
+        </p:spPr>
+        <p:txBody>
+          <a:bodyPr wrap="none" lIns="0" tIns="0" rIns="0" bIns="0"/>
+          <a:p>
+            <a:pPr algn="l">
+              <a:lnSpc>
+                <a:spcPct val="100000"/>
+              </a:lnSpc>
+            </a:pPr>
+            <a:r>
+              <a:rPr lang="zh-CN" sz="1275">
+                <a:solidFill>
+                  <a:srgbClr val="4A5568"/>
+                </a:solidFill>
+                <a:latin typeface="微软雅黑" panose="020B0503020204020204" charset="-122"/>
+                <a:ea typeface="微软雅黑" panose="020B0503020204020204" charset="-122"/>
+              </a:rPr>
+              <a:t>手工开发云模拟器工程量大、且跟不上变化</a:t>
+            </a:r>
+            <a:endParaRPr lang="zh-CN" sz="1275">
+              <a:solidFill>
+                <a:srgbClr val="4A5568"/>
+              </a:solidFill>
+              <a:latin typeface="微软雅黑" panose="020B0503020204020204" charset="-122"/>
+              <a:ea typeface="微软雅黑" panose="020B0503020204020204" charset="-122"/>
+            </a:endParaRPr>
+          </a:p>
+        </p:txBody>
+      </p:sp>
+      <p:sp>
+        <p:nvSpPr>
+          <p:cNvPr id="52" name="矩形 51"/>
+          <p:cNvSpPr/>
+          <p:nvPr/>
+        </p:nvSpPr>
+        <p:spPr>
+          <a:xfrm>
+            <a:off x="76200" y="6085205"/>
+            <a:ext cx="10931525" cy="676275"/>
+          </a:xfrm>
+          <a:prstGeom prst="rect">
+            <a:avLst/>
+          </a:prstGeom>
+          <a:solidFill>
+            <a:srgbClr val="F0F5FC"/>
+          </a:solidFill>
+        </p:spPr>
+        <p:txBody>
+          <a:bodyPr/>
+          <a:p/>
+        </p:txBody>
+      </p:sp>
+      <p:pic>
+        <p:nvPicPr>
+          <p:cNvPr id="10" name="图片 9"/>
+          <p:cNvPicPr>
+            <a:picLocks noChangeAspect="1"/>
+          </p:cNvPicPr>
+          <p:nvPr/>
+        </p:nvPicPr>
+        <p:blipFill>
+          <a:blip r:embed="rId4"/>
+          <a:stretch>
+            <a:fillRect/>
+          </a:stretch>
+        </p:blipFill>
+        <p:spPr>
+          <a:xfrm>
+            <a:off x="5913120" y="942340"/>
+            <a:ext cx="5741035" cy="2665095"/>
+          </a:xfrm>
+          <a:prstGeom prst="rect">
+            <a:avLst/>
+          </a:prstGeom>
+        </p:spPr>
+      </p:pic>
+      <p:pic>
+        <p:nvPicPr>
+          <p:cNvPr id="11" name="图片 10"/>
+          <p:cNvPicPr>
+            <a:picLocks noChangeAspect="1"/>
+          </p:cNvPicPr>
+          <p:nvPr/>
+        </p:nvPicPr>
+        <p:blipFill>
+          <a:blip r:embed="rId5"/>
+          <a:stretch>
+            <a:fillRect/>
+          </a:stretch>
+        </p:blipFill>
+        <p:spPr>
+          <a:xfrm>
+            <a:off x="76200" y="1183640"/>
+            <a:ext cx="5740400" cy="2341880"/>
+          </a:xfrm>
+          <a:prstGeom prst="rect">
+            <a:avLst/>
+          </a:prstGeom>
+        </p:spPr>
+      </p:pic>
+      <p:sp>
+        <p:nvSpPr>
+          <p:cNvPr id="53" name="任意多边形 52"/>
+          <p:cNvSpPr/>
+          <p:nvPr/>
+        </p:nvSpPr>
+        <p:spPr>
+          <a:xfrm>
+            <a:off x="76200" y="6085205"/>
+            <a:ext cx="11315700" cy="676275"/>
+          </a:xfrm>
+          <a:custGeom>
+            <a:avLst/>
+            <a:gdLst/>
+            <a:ahLst/>
+            <a:cxnLst/>
+            <a:pathLst>
+              <a:path w="1188" h="71">
+                <a:moveTo>
+                  <a:pt x="0" y="0"/>
+                </a:moveTo>
+                <a:lnTo>
+                  <a:pt x="4" y="0"/>
+                </a:lnTo>
+                <a:lnTo>
+                  <a:pt x="4" y="71"/>
+                </a:lnTo>
+                <a:lnTo>
+                  <a:pt x="0" y="71"/>
+                </a:lnTo>
+                <a:close/>
+              </a:path>
+            </a:pathLst>
+          </a:custGeom>
+          <a:solidFill>
+            <a:srgbClr val="1E4FA8"/>
+          </a:solidFill>
+        </p:spPr>
+        <p:txBody>
+          <a:bodyPr/>
+          <a:p/>
+        </p:txBody>
+      </p:sp>
+      <p:sp>
+        <p:nvSpPr>
+          <p:cNvPr id="61" name="文本框 60" descr="{&quot;isTemplate&quot;:true,&quot;type&quot;:&quot;text&quot;}"/>
           <p:cNvSpPr txBox="1"/>
           <p:nvPr>
             <p:custDataLst>
@@ -4274,44 +4294,248 @@
         </p:nvSpPr>
         <p:spPr>
           <a:xfrm>
-            <a:off x="4467225" y="2228850"/>
-            <a:ext cx="3257550" cy="257175"/>
-          </a:xfrm>
-          <a:prstGeom prst="rect">
-            <a:avLst/>
-          </a:prstGeom>
-        </p:spPr>
-        <p:txBody>
-          <a:bodyPr wrap="none" lIns="0" tIns="0" rIns="0" bIns="0"/>
-          <a:p>
-            <a:pPr>
-              <a:lnSpc>
-                <a:spcPct val="100000"/>
-              </a:lnSpc>
-            </a:pPr>
-            <a:r>
-              <a:rPr lang="zh-CN" sz="1650" b="1">
-                <a:solidFill>
-                  <a:srgbClr val="0E3F8C"/>
-                </a:solidFill>
-                <a:latin typeface="微软雅黑" panose="020B0503020204020204" charset="-122"/>
-                <a:ea typeface="微软雅黑" panose="020B0503020204020204" charset="-122"/>
-              </a:rPr>
-              <a:t>建立论文方法集</a:t>
-            </a:r>
-            <a:endParaRPr lang="zh-CN" sz="1650" b="1">
-              <a:solidFill>
-                <a:srgbClr val="0E3F8C"/>
-              </a:solidFill>
-              <a:latin typeface="微软雅黑" panose="020B0503020204020204" charset="-122"/>
-              <a:ea typeface="微软雅黑" panose="020B0503020204020204" charset="-122"/>
-            </a:endParaRPr>
-          </a:p>
-        </p:txBody>
-      </p:sp>
-      <p:sp>
-        <p:nvSpPr>
-          <p:cNvPr id="80" name="文本框 79" descr="{&quot;isTemplate&quot;:true,&quot;type&quot;:&quot;text&quot;}"/>
+            <a:off x="457200" y="3843655"/>
+            <a:ext cx="4829175" cy="1951990"/>
+          </a:xfrm>
+          <a:prstGeom prst="rect">
+            <a:avLst/>
+          </a:prstGeom>
+        </p:spPr>
+        <p:txBody>
+          <a:bodyPr wrap="square" lIns="0" tIns="0" rIns="0" bIns="0">
+            <a:normAutofit fontScale="90000"/>
+          </a:bodyPr>
+          <a:p>
+            <a:pPr>
+              <a:lnSpc>
+                <a:spcPct val="160000"/>
+              </a:lnSpc>
+            </a:pPr>
+            <a:r>
+              <a:rPr lang="zh-CN" altLang="en-US" sz="1350">
+                <a:solidFill>
+                  <a:srgbClr val="4A5568"/>
+                </a:solidFill>
+                <a:latin typeface="微软雅黑" panose="020B0503020204020204" charset="-122"/>
+                <a:ea typeface="微软雅黑" panose="020B0503020204020204" charset="-122"/>
+              </a:rPr>
+              <a:t>问题：云程序测试要真云，贵/慢/危险；手工云模拟器扩展不动（</a:t>
+            </a:r>
+            <a:r>
+              <a:rPr lang="en-US" altLang="zh-CN" sz="1350">
+                <a:solidFill>
+                  <a:srgbClr val="4A5568"/>
+                </a:solidFill>
+                <a:latin typeface="微软雅黑" panose="020B0503020204020204" charset="-122"/>
+                <a:ea typeface="微软雅黑" panose="020B0503020204020204" charset="-122"/>
+              </a:rPr>
+              <a:t>LocalStack </a:t>
+            </a:r>
+            <a:r>
+              <a:rPr lang="zh-CN" altLang="en-US" sz="1350">
+                <a:solidFill>
+                  <a:srgbClr val="4A5568"/>
+                </a:solidFill>
+                <a:latin typeface="微软雅黑" panose="020B0503020204020204" charset="-122"/>
+                <a:ea typeface="微软雅黑" panose="020B0503020204020204" charset="-122"/>
+              </a:rPr>
+              <a:t>写十余年）。</a:t>
+            </a:r>
+            <a:endParaRPr lang="zh-CN" altLang="en-US" sz="1350">
+              <a:solidFill>
+                <a:srgbClr val="4A5568"/>
+              </a:solidFill>
+              <a:latin typeface="微软雅黑" panose="020B0503020204020204" charset="-122"/>
+              <a:ea typeface="微软雅黑" panose="020B0503020204020204" charset="-122"/>
+            </a:endParaRPr>
+          </a:p>
+          <a:p>
+            <a:pPr>
+              <a:lnSpc>
+                <a:spcPct val="160000"/>
+              </a:lnSpc>
+            </a:pPr>
+            <a:r>
+              <a:rPr lang="zh-CN" altLang="en-US" sz="1350">
+                <a:solidFill>
+                  <a:srgbClr val="4A5568"/>
+                </a:solidFill>
+                <a:latin typeface="微软雅黑" panose="020B0503020204020204" charset="-122"/>
+                <a:ea typeface="微软雅黑" panose="020B0503020204020204" charset="-122"/>
+              </a:rPr>
+              <a:t>做法：神经符号合成——</a:t>
+            </a:r>
+            <a:r>
+              <a:rPr lang="en-US" altLang="zh-CN" sz="1350">
+                <a:solidFill>
+                  <a:srgbClr val="4A5568"/>
+                </a:solidFill>
+                <a:latin typeface="微软雅黑" panose="020B0503020204020204" charset="-122"/>
+                <a:ea typeface="微软雅黑" panose="020B0503020204020204" charset="-122"/>
+              </a:rPr>
+              <a:t>LLM </a:t>
+            </a:r>
+            <a:r>
+              <a:rPr lang="zh-CN" altLang="en-US" sz="1350">
+                <a:solidFill>
+                  <a:srgbClr val="4A5568"/>
+                </a:solidFill>
+                <a:latin typeface="微软雅黑" panose="020B0503020204020204" charset="-122"/>
+                <a:ea typeface="微软雅黑" panose="020B0503020204020204" charset="-122"/>
+              </a:rPr>
+              <a:t>读文档写代码 + 符号抽象抑幻觉 + 真云当 </a:t>
+            </a:r>
+            <a:r>
+              <a:rPr lang="en-US" altLang="zh-CN" sz="1350">
+                <a:solidFill>
+                  <a:srgbClr val="4A5568"/>
+                </a:solidFill>
+                <a:latin typeface="微软雅黑" panose="020B0503020204020204" charset="-122"/>
+                <a:ea typeface="微软雅黑" panose="020B0503020204020204" charset="-122"/>
+              </a:rPr>
+              <a:t>oracle </a:t>
+            </a:r>
+            <a:r>
+              <a:rPr lang="zh-CN" altLang="en-US" sz="1350">
+                <a:solidFill>
+                  <a:srgbClr val="4A5568"/>
+                </a:solidFill>
+                <a:latin typeface="微软雅黑" panose="020B0503020204020204" charset="-122"/>
+                <a:ea typeface="微软雅黑" panose="020B0503020204020204" charset="-122"/>
+              </a:rPr>
+              <a:t>自动校验修复。</a:t>
+            </a:r>
+            <a:endParaRPr lang="zh-CN" altLang="en-US" sz="1350">
+              <a:solidFill>
+                <a:srgbClr val="4A5568"/>
+              </a:solidFill>
+              <a:latin typeface="微软雅黑" panose="020B0503020204020204" charset="-122"/>
+              <a:ea typeface="微软雅黑" panose="020B0503020204020204" charset="-122"/>
+            </a:endParaRPr>
+          </a:p>
+          <a:p>
+            <a:pPr>
+              <a:lnSpc>
+                <a:spcPct val="160000"/>
+              </a:lnSpc>
+            </a:pPr>
+            <a:r>
+              <a:rPr lang="zh-CN" altLang="en-US" sz="1350">
+                <a:solidFill>
+                  <a:srgbClr val="4A5568"/>
+                </a:solidFill>
+                <a:latin typeface="微软雅黑" panose="020B0503020204020204" charset="-122"/>
+                <a:ea typeface="微软雅黑" panose="020B0503020204020204" charset="-122"/>
+              </a:rPr>
+              <a:t>为什么行：</a:t>
+            </a:r>
+            <a:r>
+              <a:rPr lang="en-US" altLang="zh-CN" sz="1350">
+                <a:solidFill>
+                  <a:srgbClr val="4A5568"/>
+                </a:solidFill>
+                <a:latin typeface="微软雅黑" panose="020B0503020204020204" charset="-122"/>
+                <a:ea typeface="微软雅黑" panose="020B0503020204020204" charset="-122"/>
+              </a:rPr>
+              <a:t>LLM </a:t>
+            </a:r>
+            <a:r>
+              <a:rPr lang="zh-CN" altLang="en-US" sz="1350">
+                <a:solidFill>
+                  <a:srgbClr val="4A5568"/>
+                </a:solidFill>
+                <a:latin typeface="微软雅黑" panose="020B0503020204020204" charset="-122"/>
+                <a:ea typeface="微软雅黑" panose="020B0503020204020204" charset="-122"/>
+              </a:rPr>
+              <a:t>管广度，符号约束管精度，</a:t>
+            </a:r>
+            <a:r>
+              <a:rPr lang="en-US" altLang="zh-CN" sz="1350">
+                <a:solidFill>
+                  <a:srgbClr val="4A5568"/>
+                </a:solidFill>
+                <a:latin typeface="微软雅黑" panose="020B0503020204020204" charset="-122"/>
+                <a:ea typeface="微软雅黑" panose="020B0503020204020204" charset="-122"/>
+              </a:rPr>
+              <a:t>oracle </a:t>
+            </a:r>
+            <a:r>
+              <a:rPr lang="zh-CN" altLang="en-US" sz="1350">
+                <a:solidFill>
+                  <a:srgbClr val="4A5568"/>
+                </a:solidFill>
+                <a:latin typeface="微软雅黑" panose="020B0503020204020204" charset="-122"/>
+                <a:ea typeface="微软雅黑" panose="020B0503020204020204" charset="-122"/>
+              </a:rPr>
+              <a:t>管正确性，三者互补。</a:t>
+            </a:r>
+            <a:endParaRPr lang="zh-CN" altLang="en-US" sz="1350">
+              <a:solidFill>
+                <a:srgbClr val="4A5568"/>
+              </a:solidFill>
+              <a:latin typeface="微软雅黑" panose="020B0503020204020204" charset="-122"/>
+              <a:ea typeface="微软雅黑" panose="020B0503020204020204" charset="-122"/>
+            </a:endParaRPr>
+          </a:p>
+          <a:p>
+            <a:pPr>
+              <a:lnSpc>
+                <a:spcPct val="160000"/>
+              </a:lnSpc>
+            </a:pPr>
+            <a:r>
+              <a:rPr lang="zh-CN" altLang="en-US" sz="1350">
+                <a:solidFill>
+                  <a:srgbClr val="4A5568"/>
+                </a:solidFill>
+                <a:latin typeface="微软雅黑" panose="020B0503020204020204" charset="-122"/>
+                <a:ea typeface="微软雅黑" panose="020B0503020204020204" charset="-122"/>
+              </a:rPr>
+              <a:t>证明：</a:t>
+            </a:r>
+            <a:r>
+              <a:rPr lang="en-US" altLang="zh-CN" sz="1350">
+                <a:solidFill>
+                  <a:srgbClr val="4A5568"/>
+                </a:solidFill>
+                <a:latin typeface="微软雅黑" panose="020B0503020204020204" charset="-122"/>
+                <a:ea typeface="微软雅黑" panose="020B0503020204020204" charset="-122"/>
+              </a:rPr>
+              <a:t>AWS/GCP </a:t>
+            </a:r>
+            <a:r>
+              <a:rPr lang="zh-CN" altLang="en-US" sz="1350">
+                <a:solidFill>
+                  <a:srgbClr val="4A5568"/>
+                </a:solidFill>
+                <a:latin typeface="微软雅黑" panose="020B0503020204020204" charset="-122"/>
+                <a:ea typeface="微软雅黑" panose="020B0503020204020204" charset="-122"/>
+              </a:rPr>
+              <a:t>服务上覆盖率与精度均超 </a:t>
+            </a:r>
+            <a:r>
+              <a:rPr lang="en-US" altLang="zh-CN" sz="1350">
+                <a:solidFill>
+                  <a:srgbClr val="4A5568"/>
+                </a:solidFill>
+                <a:latin typeface="微软雅黑" panose="020B0503020204020204" charset="-122"/>
+                <a:ea typeface="微软雅黑" panose="020B0503020204020204" charset="-122"/>
+              </a:rPr>
+              <a:t>LocalStack。</a:t>
+            </a:r>
+            <a:endParaRPr lang="en-US" altLang="zh-CN" sz="1350">
+              <a:solidFill>
+                <a:srgbClr val="4A5568"/>
+              </a:solidFill>
+              <a:latin typeface="微软雅黑" panose="020B0503020204020204" charset="-122"/>
+              <a:ea typeface="微软雅黑" panose="020B0503020204020204" charset="-122"/>
+            </a:endParaRPr>
+          </a:p>
+        </p:txBody>
+      </p:sp>
+      <p:sp>
+        <p:nvSpPr>
+          <p:cNvPr id="12" name="文本框 11" descr="{&quot;isTemplate&quot;:true,&quot;type&quot;:&quot;text&quot;}"/>
           <p:cNvSpPr txBox="1"/>
           <p:nvPr>
             <p:custDataLst>
@@ -4321,55 +4545,318 @@
         </p:nvSpPr>
         <p:spPr>
           <a:xfrm>
-            <a:off x="4467225" y="2562225"/>
-            <a:ext cx="3257550" cy="504825"/>
-          </a:xfrm>
-          <a:prstGeom prst="rect">
-            <a:avLst/>
-          </a:prstGeom>
-        </p:spPr>
-        <p:txBody>
-          <a:bodyPr wrap="none" lIns="0" tIns="0" rIns="0" bIns="0"/>
-          <a:p>
-            <a:pPr>
-              <a:lnSpc>
-                <a:spcPct val="100000"/>
-              </a:lnSpc>
-            </a:pPr>
-            <a:r>
-              <a:rPr lang="en-US" altLang="zh-CN" sz="3300" b="1">
-                <a:solidFill>
-                  <a:srgbClr val="1E4FA8"/>
-                </a:solidFill>
-                <a:latin typeface="微软雅黑" panose="020B0503020204020204" charset="-122"/>
-                <a:ea typeface="微软雅黑" panose="020B0503020204020204" charset="-122"/>
-              </a:rPr>
-              <a:t>4</a:t>
-            </a:r>
-            <a:r>
-              <a:rPr lang="zh-CN" altLang="en-US" sz="3300" b="1">
-                <a:solidFill>
-                  <a:srgbClr val="1E4FA8"/>
-                </a:solidFill>
-                <a:latin typeface="微软雅黑" panose="020B0503020204020204" charset="-122"/>
-                <a:ea typeface="微软雅黑" panose="020B0503020204020204" charset="-122"/>
-                <a:cs typeface="Arial" panose="020B0604020202020204" pitchFamily="34" charset="0"/>
-              </a:rPr>
-              <a:t>类</a:t>
-            </a:r>
-            <a:endParaRPr lang="en-US" sz="3300" b="1">
-              <a:solidFill>
-                <a:srgbClr val="1E4FA8"/>
-              </a:solidFill>
-              <a:latin typeface="微软雅黑" panose="020B0503020204020204" charset="-122"/>
-              <a:ea typeface="微软雅黑" panose="020B0503020204020204" charset="-122"/>
-            </a:endParaRPr>
-          </a:p>
-        </p:txBody>
-      </p:sp>
-      <p:sp>
-        <p:nvSpPr>
-          <p:cNvPr id="81" name="文本框 80" descr="{&quot;isTemplate&quot;:true,&quot;type&quot;:&quot;text&quot;}"/>
+            <a:off x="6228080" y="3834130"/>
+            <a:ext cx="4829175" cy="1951990"/>
+          </a:xfrm>
+          <a:prstGeom prst="rect">
+            <a:avLst/>
+          </a:prstGeom>
+        </p:spPr>
+        <p:txBody>
+          <a:bodyPr wrap="square" lIns="0" tIns="0" rIns="0" bIns="0">
+            <a:normAutofit fontScale="80000"/>
+          </a:bodyPr>
+          <a:p>
+            <a:pPr>
+              <a:lnSpc>
+                <a:spcPct val="160000"/>
+              </a:lnSpc>
+            </a:pPr>
+            <a:r>
+              <a:rPr lang="zh-CN" altLang="en-US" sz="1350">
+                <a:solidFill>
+                  <a:srgbClr val="4A5568"/>
+                </a:solidFill>
+                <a:latin typeface="微软雅黑" panose="020B0503020204020204" charset="-122"/>
+                <a:ea typeface="微软雅黑" panose="020B0503020204020204" charset="-122"/>
+              </a:rPr>
+              <a:t>问题：老 </a:t>
+            </a:r>
+            <a:r>
+              <a:rPr lang="en-US" altLang="zh-CN" sz="1350">
+                <a:solidFill>
+                  <a:srgbClr val="4A5568"/>
+                </a:solidFill>
+                <a:latin typeface="微软雅黑" panose="020B0503020204020204" charset="-122"/>
+                <a:ea typeface="微软雅黑" panose="020B0503020204020204" charset="-122"/>
+              </a:rPr>
+              <a:t>benchmark </a:t>
+            </a:r>
+            <a:r>
+              <a:rPr lang="zh-CN" altLang="en-US" sz="1350">
+                <a:solidFill>
+                  <a:srgbClr val="4A5568"/>
+                </a:solidFill>
+                <a:latin typeface="微软雅黑" panose="020B0503020204020204" charset="-122"/>
+                <a:ea typeface="微软雅黑" panose="020B0503020204020204" charset="-122"/>
+              </a:rPr>
+              <a:t>不考"多轮交互 + 守规则"，而这正是客服智能体上线必须的。</a:t>
+            </a:r>
+            <a:endParaRPr lang="zh-CN" altLang="en-US" sz="1350">
+              <a:solidFill>
+                <a:srgbClr val="4A5568"/>
+              </a:solidFill>
+              <a:latin typeface="微软雅黑" panose="020B0503020204020204" charset="-122"/>
+              <a:ea typeface="微软雅黑" panose="020B0503020204020204" charset="-122"/>
+            </a:endParaRPr>
+          </a:p>
+          <a:p>
+            <a:pPr>
+              <a:lnSpc>
+                <a:spcPct val="160000"/>
+              </a:lnSpc>
+            </a:pPr>
+            <a:r>
+              <a:rPr lang="zh-CN" altLang="en-US" sz="1350">
+                <a:solidFill>
+                  <a:srgbClr val="4A5568"/>
+                </a:solidFill>
+                <a:latin typeface="微软雅黑" panose="020B0503020204020204" charset="-122"/>
+                <a:ea typeface="微软雅黑" panose="020B0503020204020204" charset="-122"/>
+              </a:rPr>
+              <a:t>做法：模拟「用户(</a:t>
+            </a:r>
+            <a:r>
+              <a:rPr lang="en-US" altLang="zh-CN" sz="1350">
+                <a:solidFill>
+                  <a:srgbClr val="4A5568"/>
+                </a:solidFill>
+                <a:latin typeface="微软雅黑" panose="020B0503020204020204" charset="-122"/>
+                <a:ea typeface="微软雅黑" panose="020B0503020204020204" charset="-122"/>
+              </a:rPr>
+              <a:t>LLM)↔</a:t>
+            </a:r>
+            <a:r>
+              <a:rPr lang="zh-CN" altLang="en-US" sz="1350">
+                <a:solidFill>
+                  <a:srgbClr val="4A5568"/>
+                </a:solidFill>
+                <a:latin typeface="微软雅黑" panose="020B0503020204020204" charset="-122"/>
+                <a:ea typeface="微软雅黑" panose="020B0503020204020204" charset="-122"/>
+              </a:rPr>
+              <a:t>智能体(</a:t>
+            </a:r>
+            <a:r>
+              <a:rPr lang="en-US" altLang="zh-CN" sz="1350">
+                <a:solidFill>
+                  <a:srgbClr val="4A5568"/>
+                </a:solidFill>
+                <a:latin typeface="微软雅黑" panose="020B0503020204020204" charset="-122"/>
+                <a:ea typeface="微软雅黑" panose="020B0503020204020204" charset="-122"/>
+              </a:rPr>
+              <a:t>API+policy)↔</a:t>
+            </a:r>
+            <a:r>
+              <a:rPr lang="zh-CN" altLang="en-US" sz="1350">
+                <a:solidFill>
+                  <a:srgbClr val="4A5568"/>
+                </a:solidFill>
+                <a:latin typeface="微软雅黑" panose="020B0503020204020204" charset="-122"/>
+                <a:ea typeface="微软雅黑" panose="020B0503020204020204" charset="-122"/>
+              </a:rPr>
+              <a:t>环境(</a:t>
+            </a:r>
+            <a:r>
+              <a:rPr lang="en-US" altLang="zh-CN" sz="1350">
+                <a:solidFill>
+                  <a:srgbClr val="4A5568"/>
+                </a:solidFill>
+                <a:latin typeface="微软雅黑" panose="020B0503020204020204" charset="-122"/>
+                <a:ea typeface="微软雅黑" panose="020B0503020204020204" charset="-122"/>
+              </a:rPr>
+              <a:t>DB)」</a:t>
+            </a:r>
+            <a:r>
+              <a:rPr lang="zh-CN" altLang="en-US" sz="1350">
+                <a:solidFill>
+                  <a:srgbClr val="4A5568"/>
+                </a:solidFill>
+                <a:latin typeface="微软雅黑" panose="020B0503020204020204" charset="-122"/>
+                <a:ea typeface="微软雅黑" panose="020B0503020204020204" charset="-122"/>
+              </a:rPr>
+              <a:t>多轮对话；比终态 </a:t>
+            </a:r>
+            <a:r>
+              <a:rPr lang="en-US" altLang="zh-CN" sz="1350">
+                <a:solidFill>
+                  <a:srgbClr val="4A5568"/>
+                </a:solidFill>
+                <a:latin typeface="微软雅黑" panose="020B0503020204020204" charset="-122"/>
+                <a:ea typeface="微软雅黑" panose="020B0503020204020204" charset="-122"/>
+              </a:rPr>
+              <a:t>DB </a:t>
+            </a:r>
+            <a:r>
+              <a:rPr lang="zh-CN" altLang="en-US" sz="1350">
+                <a:solidFill>
+                  <a:srgbClr val="4A5568"/>
+                </a:solidFill>
+                <a:latin typeface="微软雅黑" panose="020B0503020204020204" charset="-122"/>
+                <a:ea typeface="微软雅黑" panose="020B0503020204020204" charset="-122"/>
+              </a:rPr>
+              <a:t>与目标态；新提 </a:t>
+            </a:r>
+            <a:r>
+              <a:rPr lang="en-US" altLang="zh-CN" sz="1350">
+                <a:solidFill>
+                  <a:srgbClr val="4A5568"/>
+                </a:solidFill>
+                <a:latin typeface="微软雅黑" panose="020B0503020204020204" charset="-122"/>
+                <a:ea typeface="微软雅黑" panose="020B0503020204020204" charset="-122"/>
+              </a:rPr>
+              <a:t>pass^k（</a:t>
+            </a:r>
+            <a:r>
+              <a:rPr lang="zh-CN" altLang="en-US" sz="1350">
+                <a:solidFill>
+                  <a:srgbClr val="4A5568"/>
+                </a:solidFill>
+                <a:latin typeface="微软雅黑" panose="020B0503020204020204" charset="-122"/>
+                <a:ea typeface="微软雅黑" panose="020B0503020204020204" charset="-122"/>
+              </a:rPr>
+              <a:t>连跑 </a:t>
+            </a:r>
+            <a:r>
+              <a:rPr lang="en-US" altLang="zh-CN" sz="1350">
+                <a:solidFill>
+                  <a:srgbClr val="4A5568"/>
+                </a:solidFill>
+                <a:latin typeface="微软雅黑" panose="020B0503020204020204" charset="-122"/>
+                <a:ea typeface="微软雅黑" panose="020B0503020204020204" charset="-122"/>
+              </a:rPr>
+              <a:t>k </a:t>
+            </a:r>
+            <a:r>
+              <a:rPr lang="zh-CN" altLang="en-US" sz="1350">
+                <a:solidFill>
+                  <a:srgbClr val="4A5568"/>
+                </a:solidFill>
+                <a:latin typeface="微软雅黑" panose="020B0503020204020204" charset="-122"/>
+                <a:ea typeface="微软雅黑" panose="020B0503020204020204" charset="-122"/>
+              </a:rPr>
+              <a:t>次全成功概率）。</a:t>
+            </a:r>
+            <a:endParaRPr lang="zh-CN" altLang="en-US" sz="1350">
+              <a:solidFill>
+                <a:srgbClr val="4A5568"/>
+              </a:solidFill>
+              <a:latin typeface="微软雅黑" panose="020B0503020204020204" charset="-122"/>
+              <a:ea typeface="微软雅黑" panose="020B0503020204020204" charset="-122"/>
+            </a:endParaRPr>
+          </a:p>
+          <a:p>
+            <a:pPr>
+              <a:lnSpc>
+                <a:spcPct val="160000"/>
+              </a:lnSpc>
+            </a:pPr>
+            <a:r>
+              <a:rPr lang="zh-CN" altLang="en-US" sz="1350">
+                <a:solidFill>
+                  <a:srgbClr val="4A5568"/>
+                </a:solidFill>
+                <a:latin typeface="微软雅黑" panose="020B0503020204020204" charset="-122"/>
+                <a:ea typeface="微软雅黑" panose="020B0503020204020204" charset="-122"/>
+              </a:rPr>
+              <a:t>为什么行：状态化评估可验证、用户模拟逼问清确认、</a:t>
+            </a:r>
+            <a:r>
+              <a:rPr lang="en-US" altLang="zh-CN" sz="1350">
+                <a:solidFill>
+                  <a:srgbClr val="4A5568"/>
+                </a:solidFill>
+                <a:latin typeface="微软雅黑" panose="020B0503020204020204" charset="-122"/>
+                <a:ea typeface="微软雅黑" panose="020B0503020204020204" charset="-122"/>
+              </a:rPr>
+              <a:t>pass^k </a:t>
+            </a:r>
+            <a:r>
+              <a:rPr lang="zh-CN" altLang="en-US" sz="1350">
+                <a:solidFill>
+                  <a:srgbClr val="4A5568"/>
+                </a:solidFill>
+                <a:latin typeface="微软雅黑" panose="020B0503020204020204" charset="-122"/>
+                <a:ea typeface="微软雅黑" panose="020B0503020204020204" charset="-122"/>
+              </a:rPr>
+              <a:t>专治不稳定。</a:t>
+            </a:r>
+            <a:endParaRPr lang="zh-CN" altLang="en-US" sz="1350">
+              <a:solidFill>
+                <a:srgbClr val="4A5568"/>
+              </a:solidFill>
+              <a:latin typeface="微软雅黑" panose="020B0503020204020204" charset="-122"/>
+              <a:ea typeface="微软雅黑" panose="020B0503020204020204" charset="-122"/>
+            </a:endParaRPr>
+          </a:p>
+          <a:p>
+            <a:pPr>
+              <a:lnSpc>
+                <a:spcPct val="160000"/>
+              </a:lnSpc>
+            </a:pPr>
+            <a:r>
+              <a:rPr lang="zh-CN" altLang="en-US" sz="1350">
+                <a:solidFill>
+                  <a:srgbClr val="4A5568"/>
+                </a:solidFill>
+                <a:latin typeface="微软雅黑" panose="020B0503020204020204" charset="-122"/>
+                <a:ea typeface="微软雅黑" panose="020B0503020204020204" charset="-122"/>
+              </a:rPr>
+              <a:t>证明：165 任务（零售115+航空50），最强模型 </a:t>
+            </a:r>
+            <a:r>
+              <a:rPr lang="en-US" altLang="zh-CN" sz="1350">
+                <a:solidFill>
+                  <a:srgbClr val="4A5568"/>
+                </a:solidFill>
+                <a:latin typeface="微软雅黑" panose="020B0503020204020204" charset="-122"/>
+                <a:ea typeface="微软雅黑" panose="020B0503020204020204" charset="-122"/>
+              </a:rPr>
+              <a:t>gpt-4o </a:t>
+            </a:r>
+            <a:r>
+              <a:rPr lang="zh-CN" altLang="en-US" sz="1350">
+                <a:solidFill>
+                  <a:srgbClr val="4A5568"/>
+                </a:solidFill>
+                <a:latin typeface="微软雅黑" panose="020B0503020204020204" charset="-122"/>
+                <a:ea typeface="微软雅黑" panose="020B0503020204020204" charset="-122"/>
+              </a:rPr>
+              <a:t>成功率 &lt;50%、</a:t>
+            </a:r>
+            <a:r>
+              <a:rPr lang="en-US" altLang="zh-CN" sz="1350">
+                <a:solidFill>
+                  <a:srgbClr val="4A5568"/>
+                </a:solidFill>
+                <a:latin typeface="微软雅黑" panose="020B0503020204020204" charset="-122"/>
+                <a:ea typeface="微软雅黑" panose="020B0503020204020204" charset="-122"/>
+              </a:rPr>
+              <a:t>pass^8 </a:t>
+            </a:r>
+            <a:r>
+              <a:rPr lang="zh-CN" altLang="en-US" sz="1350">
+                <a:solidFill>
+                  <a:srgbClr val="4A5568"/>
+                </a:solidFill>
+                <a:latin typeface="微软雅黑" panose="020B0503020204020204" charset="-122"/>
+                <a:ea typeface="微软雅黑" panose="020B0503020204020204" charset="-122"/>
+              </a:rPr>
+              <a:t>零售 &lt;25%</a:t>
+            </a:r>
+            <a:endParaRPr lang="zh-CN" altLang="en-US" sz="1350">
+              <a:solidFill>
+                <a:srgbClr val="4A5568"/>
+              </a:solidFill>
+              <a:latin typeface="微软雅黑" panose="020B0503020204020204" charset="-122"/>
+              <a:ea typeface="微软雅黑" panose="020B0503020204020204" charset="-122"/>
+            </a:endParaRPr>
+          </a:p>
+        </p:txBody>
+      </p:sp>
+      <p:sp>
+        <p:nvSpPr>
+          <p:cNvPr id="45" name="文本框 44" descr="{&quot;isTemplate&quot;:true,&quot;type&quot;:&quot;text&quot;}"/>
           <p:cNvSpPr txBox="1"/>
           <p:nvPr>
             <p:custDataLst>
@@ -4379,8 +4866,8 @@
         </p:nvSpPr>
         <p:spPr>
           <a:xfrm>
-            <a:off x="4467225" y="3143250"/>
-            <a:ext cx="3317708" cy="409575"/>
+            <a:off x="177800" y="6256655"/>
+            <a:ext cx="6457950" cy="333375"/>
           </a:xfrm>
           <a:prstGeom prst="rect">
             <a:avLst/>
@@ -4389,22 +4876,62 @@
         <p:txBody>
           <a:bodyPr wrap="none" lIns="0" tIns="0" rIns="0" bIns="0"/>
           <a:p>
-            <a:pPr>
-              <a:lnSpc>
-                <a:spcPct val="100000"/>
-              </a:lnSpc>
-            </a:pPr>
-            <a:r>
-              <a:rPr lang="zh-CN" altLang="en-US" sz="1275">
+            <a:pPr algn="l">
+              <a:lnSpc>
+                <a:spcPct val="160000"/>
+              </a:lnSpc>
+            </a:pPr>
+            <a:r>
+              <a:rPr lang="zh-CN" sz="1350">
                 <a:solidFill>
                   <a:srgbClr val="4A5568"/>
                 </a:solidFill>
                 <a:latin typeface="微软雅黑" panose="020B0503020204020204" charset="-122"/>
                 <a:ea typeface="微软雅黑" panose="020B0503020204020204" charset="-122"/>
               </a:rPr>
-              <a:t>将论文集分为：评估、复用、轨迹生成、</a:t>
-            </a:r>
-            <a:endParaRPr lang="zh-CN" altLang="en-US" sz="1275">
+              <a:t>我们的机会点：我们可以用</a:t>
+            </a:r>
+            <a:r>
+              <a:rPr lang="en-US" altLang="zh-CN" sz="1350">
+                <a:solidFill>
+                  <a:srgbClr val="4A5568"/>
+                </a:solidFill>
+                <a:latin typeface="微软雅黑" panose="020B0503020204020204" charset="-122"/>
+                <a:ea typeface="微软雅黑" panose="020B0503020204020204" charset="-122"/>
+              </a:rPr>
+              <a:t>CloudEmu</a:t>
+            </a:r>
+            <a:r>
+              <a:rPr lang="zh-CN" altLang="en-US" sz="1350">
+                <a:solidFill>
+                  <a:srgbClr val="4A5568"/>
+                </a:solidFill>
+                <a:latin typeface="微软雅黑" panose="020B0503020204020204" charset="-122"/>
+                <a:ea typeface="微软雅黑" panose="020B0503020204020204" charset="-122"/>
+              </a:rPr>
+              <a:t>建立云模拟器，用</a:t>
+            </a:r>
+            <a:r>
+              <a:rPr lang="en-US" altLang="zh-CN" sz="1350">
+                <a:solidFill>
+                  <a:srgbClr val="4A5568"/>
+                </a:solidFill>
+                <a:latin typeface="微软雅黑" panose="020B0503020204020204" charset="-122"/>
+                <a:ea typeface="微软雅黑" panose="020B0503020204020204" charset="-122"/>
+              </a:rPr>
+              <a:t>τ-bench</a:t>
+            </a:r>
+            <a:r>
+              <a:rPr lang="zh-CN" altLang="en-US" sz="1350">
+                <a:solidFill>
+                  <a:srgbClr val="4A5568"/>
+                </a:solidFill>
+                <a:latin typeface="微软雅黑" panose="020B0503020204020204" charset="-122"/>
+                <a:ea typeface="微软雅黑" panose="020B0503020204020204" charset="-122"/>
+              </a:rPr>
+              <a:t>进行多轮交互的评测指标</a:t>
+            </a:r>
+            <a:endParaRPr lang="zh-CN" altLang="en-US" sz="1350">
               <a:solidFill>
                 <a:srgbClr val="4A5568"/>
               </a:solidFill>
@@ -4412,45 +4939,71 @@
               <a:ea typeface="微软雅黑" panose="020B0503020204020204" charset="-122"/>
             </a:endParaRPr>
           </a:p>
-          <a:p>
-            <a:pPr>
-              <a:lnSpc>
-                <a:spcPct val="100000"/>
-              </a:lnSpc>
-            </a:pPr>
-            <a:r>
-              <a:rPr lang="zh-CN" altLang="en-US" sz="1275">
-                <a:solidFill>
-                  <a:srgbClr val="4A5568"/>
-                </a:solidFill>
-                <a:latin typeface="微软雅黑" panose="020B0503020204020204" charset="-122"/>
-                <a:ea typeface="微软雅黑" panose="020B0503020204020204" charset="-122"/>
-              </a:rPr>
-              <a:t>环境生成</a:t>
-            </a:r>
-            <a:endParaRPr lang="zh-CN" sz="1275">
-              <a:solidFill>
-                <a:srgbClr val="4A5568"/>
-              </a:solidFill>
-              <a:latin typeface="微软雅黑" panose="020B0503020204020204" charset="-122"/>
-              <a:ea typeface="微软雅黑" panose="020B0503020204020204" charset="-122"/>
-            </a:endParaRPr>
-          </a:p>
-        </p:txBody>
-      </p:sp>
-      <p:sp>
-        <p:nvSpPr>
-          <p:cNvPr id="82" name="圆角矩形 81"/>
+        </p:txBody>
+      </p:sp>
+    </p:spTree>
+  </p:cSld>
+  <p:clrMapOvr>
+    <a:masterClrMapping/>
+  </p:clrMapOvr>
+</p:sld>
+</file>
+
+<file path=ppt/slides/slide6.xml><?xml version="1.0" encoding="utf-8"?>
+<p:sld xmlns:a="http://schemas.openxmlformats.org/drawingml/2006/main" xmlns:r="http://schemas.openxmlformats.org/officeDocument/2006/relationships" xmlns:p="http://schemas.openxmlformats.org/presentationml/2006/main">
+  <p:cSld>
+    <p:spTree>
+      <p:nvGrpSpPr>
+        <p:cNvPr id="72" name="" descr="&lt;Slide padding=&quot;0&quot; style={{ background: '#FFFFFF' }}&gt;&#10;  &lt;Box style={{ position: 'absolute', left: 0, top: 0, width: 1280, height: 88, background: '#0E3F8C' }} /&gt;&#10;  &lt;Text style={{ position: 'absolute', left: 40, top: 28, fontSize: 30, fontWeight: 'bold', color: '#FFFFFF', fontFamily: 'Microsoft YaHei' }}&gt;R · 结果&lt;/Text&gt;&#10;  &lt;Text style={{ position: 'absolute', right: 40, top: 32, fontSize: 16, color: 'rgba(255,255,255,0.7)', fontFamily: 'Microsoft YaHei' }}&gt;六类资料已沉淀&lt;/Text&gt;&#10;&#10;  &lt;Box style={{ flexDirection: 'column', justifyContent: 'center', height: '100%', paddingTop: 104, paddingLeft: 40, paddingRight: 40, gap: 22 }}&gt;&#10;    &lt;Box style={{ flexDirection: 'row', gap: 20 }}&gt;&#10;      {[&#10;        { k: '名词表', v: '12×4', d: '概念与英文对照' },&#10;        { k: '环境与轨迹', v: '6×3', d: '两类要素拆解' },&#10;        { k: '两篇论文', v: '5×3', d: '精读译文' },&#10;      ].map((c, i) =&gt; (&#10;        &lt;Box key={i} style={{ flex: 1, background: '#F0F5FC', border: '1px solid #D6DCE5', borderRadius: 12, padding: 22, gap: 8 }}&gt;&#10;          &lt;Text style={{ fontSize: 22, fontWeight: 'bold', color: '#0E3F8C', fontFamily: 'Microsoft YaHei' }}&gt;{c.k}&lt;/Text&gt;&#10;          &lt;Text style={{ fontSize: 44, fontWeight: 'bold', color: '#1E4FA8', fontFamily: 'Microsoft YaHei' }}&gt;{c.v}&lt;/Text&gt;&#10;          &lt;Text style={{ fontSize: 17, color: '#4A5568', fontFamily: 'Microsoft YaHei' }}&gt;{c.d}&lt;/Text&gt;&#10;        &lt;/Box&gt;&#10;      ))}&#10;    &lt;/Box&gt;&#10;    &lt;Box style={{ flexDirection: 'row', gap: 20 }}&gt;&#10;      {[&#10;        { k: '四种方法', v: '5×8', d: '方法原理矩阵' },&#10;        { k: '轨迹 vs 环境', v: '9×3', d: '对比维度' },&#10;        { k: '论文方法集', v: '4类7图', d: '落位总表', accent: true },&#10;      ].map((c, i) =&gt; (&#10;        &lt;Box key={i} style={{ flex: 1, background: c.accent ? '#1E4FA8' : '#F0F5FC', border: c.accent ? '1px solid #1E4FA8' : '1px solid #D6DCE5', borderRadius: 12, padding: 22, gap: 8 }}&gt;&#10;          &lt;Text style={{ fontSize: 22, fontWeight: 'bold', color: c.accent ? '#FFFFFF' : '#0E3F8C', fontFamily: 'Microsoft YaHei' }}&gt;{c.k}&lt;/Text&gt;&#10;          &lt;Text style={{ fontSize: 44, fontWeight: 'bold', color: c.accent ? '#FFFFFF' : '#1E4FA8', fontFamily: 'Microsoft YaHei' }}&gt;{c.v}&lt;/Text&gt;&#10;          &lt;Text style={{ fontSize: 17, color: c.accent ? 'rgba(255,255,255,0.85)' : '#4A5568', fontFamily: 'Microsoft YaHei' }}&gt;{c.d}&lt;/Text&gt;&#10;        &lt;/Box&gt;&#10;      ))}&#10;    &lt;/Box&gt;&#10;    &lt;Text style={{ fontSize: 18, color: '#1A2230', lineHeight: 1.6, fontFamily: 'Microsoft YaHei' }}&gt;&#10;      &lt;span style={{ fontWeight: 'bold', color: '#1E4FA8' }}&gt;所以呢：&lt;/span&gt;这些不是零散笔记，而是可检索、可复用的&quot;方法论文献底座&quot;——后续实验直接调用，不必从头调研。&#10;    &lt;/Text&gt;&#10;  &lt;/Box&gt;&#10;&#10;  &lt;Text style={{ position: 'absolute', right: 40, bottom: 18, fontSize: 14, color: '#8B97A8', fontFamily: 'Microsoft YaHei' }}&gt;05 / 06&lt;/Text&gt;&#10;&lt;/Slide&gt;"/>
+        <p:cNvGrpSpPr/>
+        <p:nvPr/>
+      </p:nvGrpSpPr>
+      <p:grpSpPr>
+        <a:xfrm>
+          <a:off x="0" y="0"/>
+          <a:ext cx="0" cy="0"/>
+          <a:chOff x="0" y="0"/>
+          <a:chExt cx="0" cy="0"/>
+        </a:xfrm>
+      </p:grpSpPr>
+      <p:sp>
+        <p:nvSpPr>
+          <p:cNvPr id="73" name="矩形 72">
+            <a:hlinkClick r:id="rId1" tooltip="" action="ppaction://hlinkfile"/>
+          </p:cNvPr>
+          <p:cNvSpPr/>
+          <p:nvPr/>
+        </p:nvSpPr>
+        <p:spPr>
+          <a:xfrm>
+            <a:off x="0" y="0"/>
+            <a:ext cx="12192000" cy="6858000"/>
+          </a:xfrm>
+          <a:prstGeom prst="rect">
+            <a:avLst/>
+          </a:prstGeom>
+          <a:solidFill>
+            <a:srgbClr val="FFFFFF"/>
+          </a:solidFill>
+        </p:spPr>
+        <p:txBody>
+          <a:bodyPr/>
+          <a:p/>
+        </p:txBody>
+      </p:sp>
+      <p:sp>
+        <p:nvSpPr>
+          <p:cNvPr id="74" name="圆角矩形 73"/>
           <p:cNvSpPr/>
           <p:nvPr>
             <p:custDataLst>
-              <p:tags r:id="rId9"/>
+              <p:tags r:id="rId2"/>
             </p:custDataLst>
           </p:nvPr>
         </p:nvSpPr>
         <p:spPr>
           <a:xfrm>
-            <a:off x="8124825" y="2019300"/>
+            <a:off x="381000" y="2019300"/>
             <a:ext cx="3686175" cy="1533525"/>
           </a:xfrm>
           <a:prstGeom prst="roundRect">
@@ -4475,17 +5028,17 @@
       </p:sp>
       <p:sp>
         <p:nvSpPr>
-          <p:cNvPr id="83" name="文本框 82" descr="{&quot;isTemplate&quot;:true,&quot;type&quot;:&quot;text&quot;}"/>
+          <p:cNvPr id="75" name="文本框 74" descr="{&quot;isTemplate&quot;:true,&quot;type&quot;:&quot;text&quot;}"/>
           <p:cNvSpPr txBox="1"/>
           <p:nvPr>
             <p:custDataLst>
-              <p:tags r:id="rId10"/>
+              <p:tags r:id="rId3"/>
             </p:custDataLst>
           </p:nvPr>
         </p:nvSpPr>
         <p:spPr>
           <a:xfrm>
-            <a:off x="8334375" y="2228850"/>
+            <a:off x="590550" y="2228850"/>
             <a:ext cx="3267075" cy="257175"/>
           </a:xfrm>
           <a:prstGeom prst="rect">
@@ -4508,39 +5061,9 @@
                 <a:latin typeface="微软雅黑" panose="020B0503020204020204" charset="-122"/>
                 <a:ea typeface="微软雅黑" panose="020B0503020204020204" charset="-122"/>
               </a:rPr>
-              <a:t>论文集合</a:t>
-            </a:r>
-            <a:r>
-              <a:rPr lang="en-US" altLang="zh-CN" sz="1650" b="1">
-                <a:solidFill>
-                  <a:srgbClr val="0E3F8C"/>
-                </a:solidFill>
-                <a:latin typeface="微软雅黑" panose="020B0503020204020204" charset="-122"/>
-                <a:ea typeface="微软雅黑" panose="020B0503020204020204" charset="-122"/>
-              </a:rPr>
-              <a:t>-</a:t>
-            </a:r>
-            <a:r>
-              <a:rPr lang="zh-CN" altLang="en-US" sz="1650" b="1">
-                <a:solidFill>
-                  <a:srgbClr val="0E3F8C"/>
-                </a:solidFill>
-                <a:latin typeface="微软雅黑" panose="020B0503020204020204" charset="-122"/>
-                <a:ea typeface="微软雅黑" panose="020B0503020204020204" charset="-122"/>
-              </a:rPr>
-              <a:t>网页呈现</a:t>
-            </a:r>
-            <a:r>
-              <a:rPr lang="en-US" altLang="zh-CN" sz="1650" b="1">
-                <a:solidFill>
-                  <a:srgbClr val="0E3F8C"/>
-                </a:solidFill>
-                <a:latin typeface="微软雅黑" panose="020B0503020204020204" charset="-122"/>
-                <a:ea typeface="微软雅黑" panose="020B0503020204020204" charset="-122"/>
-              </a:rPr>
-              <a:t>skill</a:t>
-            </a:r>
-            <a:endParaRPr lang="en-US" altLang="zh-CN" sz="1650" b="1">
+              <a:t>发现关联性论文</a:t>
+            </a:r>
+            <a:endParaRPr lang="zh-CN" sz="1650" b="1">
               <a:solidFill>
                 <a:srgbClr val="0E3F8C"/>
               </a:solidFill>
@@ -4552,17 +5075,17 @@
       </p:sp>
       <p:sp>
         <p:nvSpPr>
-          <p:cNvPr id="84" name="文本框 83" descr="{&quot;isTemplate&quot;:true,&quot;type&quot;:&quot;text&quot;}"/>
+          <p:cNvPr id="76" name="文本框 75" descr="{&quot;isTemplate&quot;:true,&quot;type&quot;:&quot;text&quot;}"/>
           <p:cNvSpPr txBox="1"/>
           <p:nvPr>
             <p:custDataLst>
-              <p:tags r:id="rId11"/>
+              <p:tags r:id="rId4"/>
             </p:custDataLst>
           </p:nvPr>
         </p:nvSpPr>
         <p:spPr>
           <a:xfrm>
-            <a:off x="8334375" y="2562225"/>
+            <a:off x="590550" y="2562225"/>
             <a:ext cx="3267075" cy="504825"/>
           </a:xfrm>
           <a:prstGeom prst="rect">
@@ -4585,7 +5108,7 @@
                 <a:latin typeface="微软雅黑" panose="020B0503020204020204" charset="-122"/>
                 <a:ea typeface="微软雅黑" panose="020B0503020204020204" charset="-122"/>
               </a:rPr>
-              <a:t>1</a:t>
+              <a:t>25</a:t>
             </a:r>
             <a:r>
               <a:rPr lang="zh-CN" altLang="en-US" sz="3300" b="1">
@@ -4594,9 +5117,18 @@
                 </a:solidFill>
                 <a:latin typeface="微软雅黑" panose="020B0503020204020204" charset="-122"/>
                 <a:ea typeface="微软雅黑" panose="020B0503020204020204" charset="-122"/>
-                <a:cs typeface="Arial" panose="020B0604020202020204" pitchFamily="34" charset="0"/>
-              </a:rPr>
-              <a:t>个</a:t>
+              </a:rPr>
+              <a:t>-</a:t>
+            </a:r>
+            <a:r>
+              <a:rPr lang="en-US" altLang="zh-CN" sz="3300" b="1">
+                <a:solidFill>
+                  <a:srgbClr val="1E4FA8"/>
+                </a:solidFill>
+                <a:latin typeface="微软雅黑" panose="020B0503020204020204" charset="-122"/>
+                <a:ea typeface="微软雅黑" panose="020B0503020204020204" charset="-122"/>
+              </a:rPr>
+              <a:t>2</a:t>
             </a:r>
             <a:endParaRPr lang="en-US" sz="3300" b="1">
               <a:solidFill>
@@ -4610,18 +5142,18 @@
       </p:sp>
       <p:sp>
         <p:nvSpPr>
-          <p:cNvPr id="85" name="文本框 84" descr="{&quot;isTemplate&quot;:true,&quot;type&quot;:&quot;text&quot;}"/>
+          <p:cNvPr id="77" name="文本框 76" descr="{&quot;isTemplate&quot;:true,&quot;type&quot;:&quot;text&quot;}"/>
           <p:cNvSpPr txBox="1"/>
           <p:nvPr>
             <p:custDataLst>
-              <p:tags r:id="rId12"/>
+              <p:tags r:id="rId5"/>
             </p:custDataLst>
           </p:nvPr>
         </p:nvSpPr>
         <p:spPr>
           <a:xfrm>
-            <a:off x="8334375" y="3143250"/>
-            <a:ext cx="3267075" cy="340393"/>
+            <a:off x="590550" y="3143250"/>
+            <a:ext cx="3267075" cy="200025"/>
           </a:xfrm>
           <a:prstGeom prst="rect">
             <a:avLst/>
@@ -4643,39 +5175,29 @@
                 <a:latin typeface="微软雅黑" panose="020B0503020204020204" charset="-122"/>
                 <a:ea typeface="微软雅黑" panose="020B0503020204020204" charset="-122"/>
               </a:rPr>
-              <a:t>将</a:t>
+              <a:t>在</a:t>
+            </a:r>
+            <a:r>
+              <a:rPr lang="en-US" altLang="zh-CN" sz="1275">
+                <a:solidFill>
+                  <a:srgbClr val="4A5568"/>
+                </a:solidFill>
+                <a:latin typeface="微软雅黑" panose="020B0503020204020204" charset="-122"/>
+                <a:ea typeface="微软雅黑" panose="020B0503020204020204" charset="-122"/>
+              </a:rPr>
+              <a:t>25</a:t>
             </a:r>
             <a:r>
               <a:rPr lang="zh-CN" altLang="en-US" sz="1275">
                 <a:solidFill>
                   <a:srgbClr val="4A5568"/>
                 </a:solidFill>
-                <a:latin typeface="微软雅黑" charset="0"/>
-                <a:ea typeface="微软雅黑" charset="0"/>
-              </a:rPr>
-              <a:t>调研方向</a:t>
-            </a:r>
-            <a:r>
-              <a:rPr lang="zh-CN" altLang="en-US" sz="1275">
-                <a:solidFill>
-                  <a:srgbClr val="4A5568"/>
-                </a:solidFill>
-                <a:latin typeface="微软雅黑" panose="020B0503020204020204" charset="-122"/>
-                <a:ea typeface="微软雅黑" panose="020B0503020204020204" charset="-122"/>
-              </a:rPr>
-              <a:t>到论文网页展示的过程整理为</a:t>
-            </a:r>
-            <a:r>
-              <a:rPr lang="en-US" altLang="zh-CN" sz="1275">
-                <a:solidFill>
-                  <a:srgbClr val="4A5568"/>
-                </a:solidFill>
-                <a:latin typeface="微软雅黑" panose="020B0503020204020204" charset="-122"/>
-                <a:ea typeface="微软雅黑" panose="020B0503020204020204" charset="-122"/>
-              </a:rPr>
-              <a:t>skill</a:t>
-            </a:r>
-            <a:endParaRPr lang="en-US" altLang="zh-CN" sz="1275">
+                <a:latin typeface="微软雅黑" panose="020B0503020204020204" charset="-122"/>
+                <a:ea typeface="微软雅黑" panose="020B0503020204020204" charset="-122"/>
+              </a:rPr>
+              <a:t>篇相关论文中，找到两篇相关度最高的论文</a:t>
+            </a:r>
+            <a:endParaRPr lang="zh-CN" sz="1275">
               <a:solidFill>
                 <a:srgbClr val="4A5568"/>
               </a:solidFill>
@@ -4683,46 +5205,22 @@
               <a:ea typeface="微软雅黑" panose="020B0503020204020204" charset="-122"/>
             </a:endParaRPr>
           </a:p>
-          <a:p>
-            <a:pPr>
-              <a:lnSpc>
-                <a:spcPct val="100000"/>
-              </a:lnSpc>
-            </a:pPr>
-            <a:r>
-              <a:rPr lang="zh-CN" altLang="en-US" sz="1275">
-                <a:solidFill>
-                  <a:srgbClr val="4A5568"/>
-                </a:solidFill>
-                <a:latin typeface="微软雅黑" panose="020B0503020204020204" charset="-122"/>
-                <a:ea typeface="微软雅黑" panose="020B0503020204020204" charset="-122"/>
-              </a:rPr>
-              <a:t>方便下次使用</a:t>
-            </a:r>
-            <a:endParaRPr lang="zh-CN" sz="1275">
-              <a:solidFill>
-                <a:srgbClr val="4A5568"/>
-              </a:solidFill>
-              <a:latin typeface="微软雅黑" panose="020B0503020204020204" charset="-122"/>
-              <a:ea typeface="微软雅黑" panose="020B0503020204020204" charset="-122"/>
-            </a:endParaRPr>
-          </a:p>
-        </p:txBody>
-      </p:sp>
-      <p:sp>
-        <p:nvSpPr>
-          <p:cNvPr id="86" name="圆角矩形 85"/>
+        </p:txBody>
+      </p:sp>
+      <p:sp>
+        <p:nvSpPr>
+          <p:cNvPr id="78" name="圆角矩形 77"/>
           <p:cNvSpPr/>
           <p:nvPr>
             <p:custDataLst>
-              <p:tags r:id="rId13"/>
+              <p:tags r:id="rId6"/>
             </p:custDataLst>
           </p:nvPr>
         </p:nvSpPr>
         <p:spPr>
           <a:xfrm>
-            <a:off x="381000" y="3762375"/>
-            <a:ext cx="3686175" cy="1533525"/>
+            <a:off x="4257675" y="2019300"/>
+            <a:ext cx="3676650" cy="1533525"/>
           </a:xfrm>
           <a:prstGeom prst="roundRect">
             <a:avLst>
@@ -4746,18 +5244,18 @@
       </p:sp>
       <p:sp>
         <p:nvSpPr>
-          <p:cNvPr id="87" name="文本框 86" descr="{&quot;isTemplate&quot;:true,&quot;type&quot;:&quot;text&quot;}"/>
+          <p:cNvPr id="79" name="文本框 78" descr="{&quot;isTemplate&quot;:true,&quot;type&quot;:&quot;text&quot;}"/>
           <p:cNvSpPr txBox="1"/>
           <p:nvPr>
             <p:custDataLst>
-              <p:tags r:id="rId14"/>
+              <p:tags r:id="rId7"/>
             </p:custDataLst>
           </p:nvPr>
         </p:nvSpPr>
         <p:spPr>
           <a:xfrm>
-            <a:off x="590550" y="3971925"/>
-            <a:ext cx="3267075" cy="257175"/>
+            <a:off x="4467225" y="2228850"/>
+            <a:ext cx="3257550" cy="257175"/>
           </a:xfrm>
           <a:prstGeom prst="rect">
             <a:avLst/>
@@ -4779,7 +5277,7 @@
                 <a:latin typeface="微软雅黑" panose="020B0503020204020204" charset="-122"/>
                 <a:ea typeface="微软雅黑" panose="020B0503020204020204" charset="-122"/>
               </a:rPr>
-              <a:t>工程日志</a:t>
+              <a:t>建立论文方法集</a:t>
             </a:r>
             <a:endParaRPr lang="zh-CN" sz="1650" b="1">
               <a:solidFill>
@@ -4793,18 +5291,18 @@
       </p:sp>
       <p:sp>
         <p:nvSpPr>
-          <p:cNvPr id="88" name="文本框 87" descr="{&quot;isTemplate&quot;:true,&quot;type&quot;:&quot;text&quot;}"/>
+          <p:cNvPr id="80" name="文本框 79" descr="{&quot;isTemplate&quot;:true,&quot;type&quot;:&quot;text&quot;}"/>
           <p:cNvSpPr txBox="1"/>
           <p:nvPr>
             <p:custDataLst>
-              <p:tags r:id="rId15"/>
+              <p:tags r:id="rId8"/>
             </p:custDataLst>
           </p:nvPr>
         </p:nvSpPr>
         <p:spPr>
           <a:xfrm>
-            <a:off x="590550" y="4305300"/>
-            <a:ext cx="3267075" cy="504825"/>
+            <a:off x="4467225" y="2562225"/>
+            <a:ext cx="3257550" cy="504825"/>
           </a:xfrm>
           <a:prstGeom prst="rect">
             <a:avLst/>
@@ -4819,47 +5317,50 @@
               </a:lnSpc>
             </a:pPr>
             <a:r>
-              <a:rPr lang="en-US" sz="3300" b="1">
+              <a:rPr lang="en-US" altLang="zh-CN" sz="3300" b="1">
                 <a:solidFill>
                   <a:srgbClr val="1E4FA8"/>
                 </a:solidFill>
-                <a:latin typeface="微软雅黑" charset="0"/>
-                <a:ea typeface="微软雅黑" charset="0"/>
-              </a:rPr>
-              <a:t>1</a:t>
+                <a:latin typeface="微软雅黑" panose="020B0503020204020204" charset="-122"/>
+                <a:ea typeface="微软雅黑" panose="020B0503020204020204" charset="-122"/>
+              </a:rPr>
+              <a:t>4</a:t>
             </a:r>
             <a:r>
               <a:rPr lang="zh-CN" altLang="en-US" sz="3300" b="1">
                 <a:solidFill>
                   <a:srgbClr val="1E4FA8"/>
                 </a:solidFill>
-                <a:latin typeface="微软雅黑" charset="0"/>
-                <a:ea typeface="微软雅黑" charset="0"/>
+                <a:latin typeface="微软雅黑" panose="020B0503020204020204" charset="-122"/>
+                <a:ea typeface="微软雅黑" panose="020B0503020204020204" charset="-122"/>
                 <a:cs typeface="Arial" panose="020B0604020202020204" pitchFamily="34" charset="0"/>
               </a:rPr>
-              <a:t>篇</a:t>
-            </a:r>
-            <a:endParaRPr lang="en-US">
-              <a:latin typeface="微软雅黑" panose="020B0503020204020204" charset="-122"/>
-              <a:ea typeface="微软雅黑" panose="020B0503020204020204" charset="-122"/>
-            </a:endParaRPr>
-          </a:p>
-        </p:txBody>
-      </p:sp>
-      <p:sp>
-        <p:nvSpPr>
-          <p:cNvPr id="89" name="文本框 88" descr="{&quot;isTemplate&quot;:true,&quot;type&quot;:&quot;text&quot;}"/>
+              <a:t>类</a:t>
+            </a:r>
+            <a:endParaRPr lang="en-US" sz="3300" b="1">
+              <a:solidFill>
+                <a:srgbClr val="1E4FA8"/>
+              </a:solidFill>
+              <a:latin typeface="微软雅黑" panose="020B0503020204020204" charset="-122"/>
+              <a:ea typeface="微软雅黑" panose="020B0503020204020204" charset="-122"/>
+            </a:endParaRPr>
+          </a:p>
+        </p:txBody>
+      </p:sp>
+      <p:sp>
+        <p:nvSpPr>
+          <p:cNvPr id="81" name="文本框 80" descr="{&quot;isTemplate&quot;:true,&quot;type&quot;:&quot;text&quot;}"/>
           <p:cNvSpPr txBox="1"/>
           <p:nvPr>
             <p:custDataLst>
-              <p:tags r:id="rId16"/>
+              <p:tags r:id="rId9"/>
             </p:custDataLst>
           </p:nvPr>
         </p:nvSpPr>
         <p:spPr>
           <a:xfrm>
-            <a:off x="590550" y="4886325"/>
-            <a:ext cx="3267075" cy="200025"/>
+            <a:off x="4467225" y="3143250"/>
+            <a:ext cx="3317708" cy="409575"/>
           </a:xfrm>
           <a:prstGeom prst="rect">
             <a:avLst/>
@@ -4874,14 +5375,38 @@
               </a:lnSpc>
             </a:pPr>
             <a:r>
-              <a:rPr lang="zh-CN" sz="1275">
+              <a:rPr lang="zh-CN" altLang="en-US" sz="1275">
                 <a:solidFill>
                   <a:srgbClr val="4A5568"/>
                 </a:solidFill>
                 <a:latin typeface="微软雅黑" panose="020B0503020204020204" charset="-122"/>
                 <a:ea typeface="微软雅黑" panose="020B0503020204020204" charset="-122"/>
               </a:rPr>
-              <a:t>方法原理矩阵</a:t>
+              <a:t>将论文集分为：评估、复用、轨迹生成、</a:t>
+            </a:r>
+            <a:endParaRPr lang="zh-CN" altLang="en-US" sz="1275">
+              <a:solidFill>
+                <a:srgbClr val="4A5568"/>
+              </a:solidFill>
+              <a:latin typeface="微软雅黑" panose="020B0503020204020204" charset="-122"/>
+              <a:ea typeface="微软雅黑" panose="020B0503020204020204" charset="-122"/>
+            </a:endParaRPr>
+          </a:p>
+          <a:p>
+            <a:pPr>
+              <a:lnSpc>
+                <a:spcPct val="100000"/>
+              </a:lnSpc>
+            </a:pPr>
+            <a:r>
+              <a:rPr lang="zh-CN" altLang="en-US" sz="1275">
+                <a:solidFill>
+                  <a:srgbClr val="4A5568"/>
+                </a:solidFill>
+                <a:latin typeface="微软雅黑" panose="020B0503020204020204" charset="-122"/>
+                <a:ea typeface="微软雅黑" panose="020B0503020204020204" charset="-122"/>
+              </a:rPr>
+              <a:t>环境生成</a:t>
             </a:r>
             <a:endParaRPr lang="zh-CN" sz="1275">
               <a:solidFill>
@@ -4895,18 +5420,18 @@
       </p:sp>
       <p:sp>
         <p:nvSpPr>
-          <p:cNvPr id="90" name="圆角矩形 89"/>
+          <p:cNvPr id="82" name="圆角矩形 81"/>
           <p:cNvSpPr/>
           <p:nvPr>
             <p:custDataLst>
-              <p:tags r:id="rId17"/>
+              <p:tags r:id="rId10"/>
             </p:custDataLst>
           </p:nvPr>
         </p:nvSpPr>
         <p:spPr>
           <a:xfrm>
-            <a:off x="4257675" y="3762375"/>
-            <a:ext cx="3676650" cy="1533525"/>
+            <a:off x="8124825" y="2019300"/>
+            <a:ext cx="3686175" cy="1533525"/>
           </a:xfrm>
           <a:prstGeom prst="roundRect">
             <a:avLst>
@@ -4930,8 +5455,418 @@
       </p:sp>
       <p:sp>
         <p:nvSpPr>
-          <p:cNvPr id="91" name="文本框 90" descr="{&quot;isTemplate&quot;:true,&quot;type&quot;:&quot;text&quot;}"/>
+          <p:cNvPr id="83" name="文本框 82" descr="{&quot;isTemplate&quot;:true,&quot;type&quot;:&quot;text&quot;}"/>
           <p:cNvSpPr txBox="1"/>
+          <p:nvPr>
+            <p:custDataLst>
+              <p:tags r:id="rId11"/>
+            </p:custDataLst>
+          </p:nvPr>
+        </p:nvSpPr>
+        <p:spPr>
+          <a:xfrm>
+            <a:off x="8334375" y="2228850"/>
+            <a:ext cx="3267075" cy="257175"/>
+          </a:xfrm>
+          <a:prstGeom prst="rect">
+            <a:avLst/>
+          </a:prstGeom>
+        </p:spPr>
+        <p:txBody>
+          <a:bodyPr wrap="none" lIns="0" tIns="0" rIns="0" bIns="0"/>
+          <a:p>
+            <a:pPr>
+              <a:lnSpc>
+                <a:spcPct val="100000"/>
+              </a:lnSpc>
+            </a:pPr>
+            <a:r>
+              <a:rPr lang="zh-CN" sz="1650" b="1">
+                <a:solidFill>
+                  <a:srgbClr val="0E3F8C"/>
+                </a:solidFill>
+                <a:latin typeface="微软雅黑" panose="020B0503020204020204" charset="-122"/>
+                <a:ea typeface="微软雅黑" panose="020B0503020204020204" charset="-122"/>
+              </a:rPr>
+              <a:t>论文集合</a:t>
+            </a:r>
+            <a:r>
+              <a:rPr lang="en-US" altLang="zh-CN" sz="1650" b="1">
+                <a:solidFill>
+                  <a:srgbClr val="0E3F8C"/>
+                </a:solidFill>
+                <a:latin typeface="微软雅黑" panose="020B0503020204020204" charset="-122"/>
+                <a:ea typeface="微软雅黑" panose="020B0503020204020204" charset="-122"/>
+              </a:rPr>
+              <a:t>-</a:t>
+            </a:r>
+            <a:r>
+              <a:rPr lang="zh-CN" altLang="en-US" sz="1650" b="1">
+                <a:solidFill>
+                  <a:srgbClr val="0E3F8C"/>
+                </a:solidFill>
+                <a:latin typeface="微软雅黑" panose="020B0503020204020204" charset="-122"/>
+                <a:ea typeface="微软雅黑" panose="020B0503020204020204" charset="-122"/>
+              </a:rPr>
+              <a:t>网页呈现</a:t>
+            </a:r>
+            <a:r>
+              <a:rPr lang="en-US" altLang="zh-CN" sz="1650" b="1">
+                <a:solidFill>
+                  <a:srgbClr val="0E3F8C"/>
+                </a:solidFill>
+                <a:latin typeface="微软雅黑" panose="020B0503020204020204" charset="-122"/>
+                <a:ea typeface="微软雅黑" panose="020B0503020204020204" charset="-122"/>
+              </a:rPr>
+              <a:t>skill</a:t>
+            </a:r>
+            <a:endParaRPr lang="en-US" altLang="zh-CN" sz="1650" b="1">
+              <a:solidFill>
+                <a:srgbClr val="0E3F8C"/>
+              </a:solidFill>
+              <a:latin typeface="微软雅黑" panose="020B0503020204020204" charset="-122"/>
+              <a:ea typeface="微软雅黑" panose="020B0503020204020204" charset="-122"/>
+            </a:endParaRPr>
+          </a:p>
+        </p:txBody>
+      </p:sp>
+      <p:sp>
+        <p:nvSpPr>
+          <p:cNvPr id="84" name="文本框 83" descr="{&quot;isTemplate&quot;:true,&quot;type&quot;:&quot;text&quot;}"/>
+          <p:cNvSpPr txBox="1"/>
+          <p:nvPr>
+            <p:custDataLst>
+              <p:tags r:id="rId12"/>
+            </p:custDataLst>
+          </p:nvPr>
+        </p:nvSpPr>
+        <p:spPr>
+          <a:xfrm>
+            <a:off x="8334375" y="2562225"/>
+            <a:ext cx="3267075" cy="504825"/>
+          </a:xfrm>
+          <a:prstGeom prst="rect">
+            <a:avLst/>
+          </a:prstGeom>
+        </p:spPr>
+        <p:txBody>
+          <a:bodyPr wrap="none" lIns="0" tIns="0" rIns="0" bIns="0"/>
+          <a:p>
+            <a:pPr>
+              <a:lnSpc>
+                <a:spcPct val="100000"/>
+              </a:lnSpc>
+            </a:pPr>
+            <a:r>
+              <a:rPr lang="en-US" altLang="zh-CN" sz="3300" b="1">
+                <a:solidFill>
+                  <a:srgbClr val="1E4FA8"/>
+                </a:solidFill>
+                <a:latin typeface="微软雅黑" panose="020B0503020204020204" charset="-122"/>
+                <a:ea typeface="微软雅黑" panose="020B0503020204020204" charset="-122"/>
+              </a:rPr>
+              <a:t>1</a:t>
+            </a:r>
+            <a:r>
+              <a:rPr lang="zh-CN" altLang="en-US" sz="3300" b="1">
+                <a:solidFill>
+                  <a:srgbClr val="1E4FA8"/>
+                </a:solidFill>
+                <a:latin typeface="微软雅黑" panose="020B0503020204020204" charset="-122"/>
+                <a:ea typeface="微软雅黑" panose="020B0503020204020204" charset="-122"/>
+                <a:cs typeface="Arial" panose="020B0604020202020204" pitchFamily="34" charset="0"/>
+              </a:rPr>
+              <a:t>个</a:t>
+            </a:r>
+            <a:endParaRPr lang="en-US" sz="3300" b="1">
+              <a:solidFill>
+                <a:srgbClr val="1E4FA8"/>
+              </a:solidFill>
+              <a:latin typeface="微软雅黑" panose="020B0503020204020204" charset="-122"/>
+              <a:ea typeface="微软雅黑" panose="020B0503020204020204" charset="-122"/>
+            </a:endParaRPr>
+          </a:p>
+        </p:txBody>
+      </p:sp>
+      <p:sp>
+        <p:nvSpPr>
+          <p:cNvPr id="85" name="文本框 84" descr="{&quot;isTemplate&quot;:true,&quot;type&quot;:&quot;text&quot;}"/>
+          <p:cNvSpPr txBox="1"/>
+          <p:nvPr>
+            <p:custDataLst>
+              <p:tags r:id="rId13"/>
+            </p:custDataLst>
+          </p:nvPr>
+        </p:nvSpPr>
+        <p:spPr>
+          <a:xfrm>
+            <a:off x="8334375" y="3143250"/>
+            <a:ext cx="3267075" cy="340393"/>
+          </a:xfrm>
+          <a:prstGeom prst="rect">
+            <a:avLst/>
+          </a:prstGeom>
+        </p:spPr>
+        <p:txBody>
+          <a:bodyPr wrap="none" lIns="0" tIns="0" rIns="0" bIns="0"/>
+          <a:p>
+            <a:pPr>
+              <a:lnSpc>
+                <a:spcPct val="100000"/>
+              </a:lnSpc>
+            </a:pPr>
+            <a:r>
+              <a:rPr lang="zh-CN" altLang="en-US" sz="1275">
+                <a:solidFill>
+                  <a:srgbClr val="4A5568"/>
+                </a:solidFill>
+                <a:latin typeface="微软雅黑" panose="020B0503020204020204" charset="-122"/>
+                <a:ea typeface="微软雅黑" panose="020B0503020204020204" charset="-122"/>
+              </a:rPr>
+              <a:t>将</a:t>
+            </a:r>
+            <a:r>
+              <a:rPr lang="zh-CN" altLang="en-US" sz="1275">
+                <a:solidFill>
+                  <a:srgbClr val="4A5568"/>
+                </a:solidFill>
+                <a:latin typeface="微软雅黑" panose="020B0503020204020204" charset="-122"/>
+                <a:ea typeface="微软雅黑" panose="020B0503020204020204" charset="-122"/>
+              </a:rPr>
+              <a:t>调研方向</a:t>
+            </a:r>
+            <a:r>
+              <a:rPr lang="zh-CN" altLang="en-US" sz="1275">
+                <a:solidFill>
+                  <a:srgbClr val="4A5568"/>
+                </a:solidFill>
+                <a:latin typeface="微软雅黑" panose="020B0503020204020204" charset="-122"/>
+                <a:ea typeface="微软雅黑" panose="020B0503020204020204" charset="-122"/>
+              </a:rPr>
+              <a:t>到论文网页展示的过程整理为</a:t>
+            </a:r>
+            <a:r>
+              <a:rPr lang="en-US" altLang="zh-CN" sz="1275">
+                <a:solidFill>
+                  <a:srgbClr val="4A5568"/>
+                </a:solidFill>
+                <a:latin typeface="微软雅黑" panose="020B0503020204020204" charset="-122"/>
+                <a:ea typeface="微软雅黑" panose="020B0503020204020204" charset="-122"/>
+              </a:rPr>
+              <a:t>skill</a:t>
+            </a:r>
+            <a:endParaRPr lang="en-US" altLang="zh-CN" sz="1275">
+              <a:solidFill>
+                <a:srgbClr val="4A5568"/>
+              </a:solidFill>
+              <a:latin typeface="微软雅黑" panose="020B0503020204020204" charset="-122"/>
+              <a:ea typeface="微软雅黑" panose="020B0503020204020204" charset="-122"/>
+            </a:endParaRPr>
+          </a:p>
+          <a:p>
+            <a:pPr>
+              <a:lnSpc>
+                <a:spcPct val="100000"/>
+              </a:lnSpc>
+            </a:pPr>
+            <a:r>
+              <a:rPr lang="zh-CN" altLang="en-US" sz="1275">
+                <a:solidFill>
+                  <a:srgbClr val="4A5568"/>
+                </a:solidFill>
+                <a:latin typeface="微软雅黑" panose="020B0503020204020204" charset="-122"/>
+                <a:ea typeface="微软雅黑" panose="020B0503020204020204" charset="-122"/>
+              </a:rPr>
+              <a:t>方便下次使用</a:t>
+            </a:r>
+            <a:endParaRPr lang="zh-CN" sz="1275">
+              <a:solidFill>
+                <a:srgbClr val="4A5568"/>
+              </a:solidFill>
+              <a:latin typeface="微软雅黑" panose="020B0503020204020204" charset="-122"/>
+              <a:ea typeface="微软雅黑" panose="020B0503020204020204" charset="-122"/>
+            </a:endParaRPr>
+          </a:p>
+        </p:txBody>
+      </p:sp>
+      <p:sp>
+        <p:nvSpPr>
+          <p:cNvPr id="86" name="圆角矩形 85"/>
+          <p:cNvSpPr/>
+          <p:nvPr>
+            <p:custDataLst>
+              <p:tags r:id="rId14"/>
+            </p:custDataLst>
+          </p:nvPr>
+        </p:nvSpPr>
+        <p:spPr>
+          <a:xfrm>
+            <a:off x="381000" y="3762375"/>
+            <a:ext cx="3686175" cy="1533525"/>
+          </a:xfrm>
+          <a:prstGeom prst="roundRect">
+            <a:avLst>
+              <a:gd name="adj" fmla="val 7453"/>
+            </a:avLst>
+          </a:prstGeom>
+          <a:solidFill>
+            <a:srgbClr val="F0F5FC"/>
+          </a:solidFill>
+          <a:ln w="12700">
+            <a:solidFill>
+              <a:srgbClr val="D6DCE5"/>
+            </a:solidFill>
+            <a:prstDash val="solid"/>
+          </a:ln>
+        </p:spPr>
+        <p:txBody>
+          <a:bodyPr/>
+          <a:p/>
+        </p:txBody>
+      </p:sp>
+      <p:sp>
+        <p:nvSpPr>
+          <p:cNvPr id="87" name="文本框 86" descr="{&quot;isTemplate&quot;:true,&quot;type&quot;:&quot;text&quot;}"/>
+          <p:cNvSpPr txBox="1"/>
+          <p:nvPr>
+            <p:custDataLst>
+              <p:tags r:id="rId15"/>
+            </p:custDataLst>
+          </p:nvPr>
+        </p:nvSpPr>
+        <p:spPr>
+          <a:xfrm>
+            <a:off x="590550" y="3971925"/>
+            <a:ext cx="3267075" cy="257175"/>
+          </a:xfrm>
+          <a:prstGeom prst="rect">
+            <a:avLst/>
+          </a:prstGeom>
+        </p:spPr>
+        <p:txBody>
+          <a:bodyPr wrap="none" lIns="0" tIns="0" rIns="0" bIns="0"/>
+          <a:p>
+            <a:pPr>
+              <a:lnSpc>
+                <a:spcPct val="100000"/>
+              </a:lnSpc>
+            </a:pPr>
+            <a:r>
+              <a:rPr lang="zh-CN" sz="1650" b="1">
+                <a:solidFill>
+                  <a:srgbClr val="0E3F8C"/>
+                </a:solidFill>
+                <a:latin typeface="微软雅黑" panose="020B0503020204020204" charset="-122"/>
+                <a:ea typeface="微软雅黑" panose="020B0503020204020204" charset="-122"/>
+              </a:rPr>
+              <a:t>工程日志</a:t>
+            </a:r>
+            <a:endParaRPr lang="zh-CN" sz="1650" b="1">
+              <a:solidFill>
+                <a:srgbClr val="0E3F8C"/>
+              </a:solidFill>
+              <a:latin typeface="微软雅黑" panose="020B0503020204020204" charset="-122"/>
+              <a:ea typeface="微软雅黑" panose="020B0503020204020204" charset="-122"/>
+            </a:endParaRPr>
+          </a:p>
+        </p:txBody>
+      </p:sp>
+      <p:sp>
+        <p:nvSpPr>
+          <p:cNvPr id="88" name="文本框 87" descr="{&quot;isTemplate&quot;:true,&quot;type&quot;:&quot;text&quot;}"/>
+          <p:cNvSpPr txBox="1"/>
+          <p:nvPr>
+            <p:custDataLst>
+              <p:tags r:id="rId16"/>
+            </p:custDataLst>
+          </p:nvPr>
+        </p:nvSpPr>
+        <p:spPr>
+          <a:xfrm>
+            <a:off x="590550" y="4305300"/>
+            <a:ext cx="3267075" cy="504825"/>
+          </a:xfrm>
+          <a:prstGeom prst="rect">
+            <a:avLst/>
+          </a:prstGeom>
+        </p:spPr>
+        <p:txBody>
+          <a:bodyPr wrap="none" lIns="0" tIns="0" rIns="0" bIns="0"/>
+          <a:p>
+            <a:pPr>
+              <a:lnSpc>
+                <a:spcPct val="100000"/>
+              </a:lnSpc>
+            </a:pPr>
+            <a:r>
+              <a:rPr lang="en-US" sz="3300" b="1">
+                <a:solidFill>
+                  <a:srgbClr val="1E4FA8"/>
+                </a:solidFill>
+                <a:latin typeface="微软雅黑" panose="020B0503020204020204" charset="-122"/>
+                <a:ea typeface="微软雅黑" panose="020B0503020204020204" charset="-122"/>
+              </a:rPr>
+              <a:t>1</a:t>
+            </a:r>
+            <a:r>
+              <a:rPr lang="zh-CN" altLang="en-US" sz="3300" b="1">
+                <a:solidFill>
+                  <a:srgbClr val="1E4FA8"/>
+                </a:solidFill>
+                <a:latin typeface="微软雅黑" panose="020B0503020204020204" charset="-122"/>
+                <a:ea typeface="微软雅黑" panose="020B0503020204020204" charset="-122"/>
+                <a:cs typeface="Arial" panose="020B0604020202020204" pitchFamily="34" charset="0"/>
+              </a:rPr>
+              <a:t>篇</a:t>
+            </a:r>
+            <a:endParaRPr lang="en-US">
+              <a:latin typeface="微软雅黑" panose="020B0503020204020204" charset="-122"/>
+              <a:ea typeface="微软雅黑" panose="020B0503020204020204" charset="-122"/>
+            </a:endParaRPr>
+          </a:p>
+        </p:txBody>
+      </p:sp>
+      <p:sp>
+        <p:nvSpPr>
+          <p:cNvPr id="89" name="文本框 88" descr="{&quot;isTemplate&quot;:true,&quot;type&quot;:&quot;text&quot;}"/>
+          <p:cNvSpPr txBox="1"/>
+          <p:nvPr>
+            <p:custDataLst>
+              <p:tags r:id="rId17"/>
+            </p:custDataLst>
+          </p:nvPr>
+        </p:nvSpPr>
+        <p:spPr>
+          <a:xfrm>
+            <a:off x="590550" y="4886325"/>
+            <a:ext cx="3267075" cy="200025"/>
+          </a:xfrm>
+          <a:prstGeom prst="rect">
+            <a:avLst/>
+          </a:prstGeom>
+        </p:spPr>
+        <p:txBody>
+          <a:bodyPr wrap="none" lIns="0" tIns="0" rIns="0" bIns="0"/>
+          <a:p>
+            <a:pPr>
+              <a:lnSpc>
+                <a:spcPct val="100000"/>
+              </a:lnSpc>
+            </a:pPr>
+            <a:endParaRPr lang="zh-CN" sz="1275">
+              <a:solidFill>
+                <a:srgbClr val="4A5568"/>
+              </a:solidFill>
+              <a:latin typeface="微软雅黑" panose="020B0503020204020204" charset="-122"/>
+              <a:ea typeface="微软雅黑" panose="020B0503020204020204" charset="-122"/>
+            </a:endParaRPr>
+          </a:p>
+        </p:txBody>
+      </p:sp>
+      <p:sp>
+        <p:nvSpPr>
+          <p:cNvPr id="90" name="圆角矩形 89"/>
+          <p:cNvSpPr/>
           <p:nvPr>
             <p:custDataLst>
               <p:tags r:id="rId18"/>
@@ -4940,44 +5875,32 @@
         </p:nvSpPr>
         <p:spPr>
           <a:xfrm>
-            <a:off x="4467225" y="3971925"/>
-            <a:ext cx="3257550" cy="257175"/>
-          </a:xfrm>
-          <a:prstGeom prst="rect">
-            <a:avLst/>
-          </a:prstGeom>
-        </p:spPr>
-        <p:txBody>
-          <a:bodyPr wrap="none" lIns="0" tIns="0" rIns="0" bIns="0"/>
-          <a:p>
-            <a:pPr>
-              <a:lnSpc>
-                <a:spcPct val="100000"/>
-              </a:lnSpc>
-            </a:pPr>
-            <a:r>
-              <a:rPr lang="zh-CN" sz="1650" b="1">
-                <a:solidFill>
-                  <a:srgbClr val="0E3F8C"/>
-                </a:solidFill>
-                <a:latin typeface="微软雅黑" panose="020B0503020204020204" charset="-122"/>
-                <a:ea typeface="微软雅黑" panose="020B0503020204020204" charset="-122"/>
-              </a:rPr>
-              <a:t>开源项目</a:t>
-            </a:r>
-            <a:endParaRPr lang="zh-CN" sz="1650" b="1">
-              <a:solidFill>
-                <a:srgbClr val="0E3F8C"/>
-              </a:solidFill>
-              <a:latin typeface="微软雅黑" panose="020B0503020204020204" charset="-122"/>
-              <a:ea typeface="微软雅黑" panose="020B0503020204020204" charset="-122"/>
-            </a:endParaRPr>
-          </a:p>
-        </p:txBody>
-      </p:sp>
-      <p:sp>
-        <p:nvSpPr>
-          <p:cNvPr id="92" name="文本框 91" descr="{&quot;isTemplate&quot;:true,&quot;type&quot;:&quot;text&quot;}"/>
+            <a:off x="4257675" y="3762375"/>
+            <a:ext cx="3676650" cy="1533525"/>
+          </a:xfrm>
+          <a:prstGeom prst="roundRect">
+            <a:avLst>
+              <a:gd name="adj" fmla="val 7453"/>
+            </a:avLst>
+          </a:prstGeom>
+          <a:solidFill>
+            <a:srgbClr val="F0F5FC"/>
+          </a:solidFill>
+          <a:ln w="12700">
+            <a:solidFill>
+              <a:srgbClr val="D6DCE5"/>
+            </a:solidFill>
+            <a:prstDash val="solid"/>
+          </a:ln>
+        </p:spPr>
+        <p:txBody>
+          <a:bodyPr/>
+          <a:p/>
+        </p:txBody>
+      </p:sp>
+      <p:sp>
+        <p:nvSpPr>
+          <p:cNvPr id="91" name="文本框 90" descr="{&quot;isTemplate&quot;:true,&quot;type&quot;:&quot;text&quot;}"/>
           <p:cNvSpPr txBox="1"/>
           <p:nvPr>
             <p:custDataLst>
@@ -4987,8 +5910,8 @@
         </p:nvSpPr>
         <p:spPr>
           <a:xfrm>
-            <a:off x="4467225" y="4305300"/>
-            <a:ext cx="3257550" cy="504825"/>
+            <a:off x="4467225" y="3971925"/>
+            <a:ext cx="3257550" cy="257175"/>
           </a:xfrm>
           <a:prstGeom prst="rect">
             <a:avLst/>
@@ -5003,39 +5926,28 @@
               </a:lnSpc>
             </a:pPr>
             <a:r>
-              <a:rPr lang="en-US" altLang="zh-CN" sz="3300" b="1">
-                <a:solidFill>
-                  <a:srgbClr val="1E4FA8"/>
-                </a:solidFill>
-                <a:latin typeface="微软雅黑" panose="020B0503020204020204" charset="-122"/>
-                <a:ea typeface="微软雅黑" panose="020B0503020204020204" charset="-122"/>
-              </a:rPr>
-              <a:t>4</a:t>
-            </a:r>
-            <a:r>
-              <a:rPr lang="zh-CN" altLang="en-US" sz="3300" b="1">
-                <a:solidFill>
-                  <a:srgbClr val="1E4FA8"/>
-                </a:solidFill>
-                <a:latin typeface="微软雅黑" panose="020B0503020204020204" charset="-122"/>
-                <a:ea typeface="微软雅黑" panose="020B0503020204020204" charset="-122"/>
-                <a:cs typeface="Arial" panose="020B0604020202020204" pitchFamily="34" charset="0"/>
-              </a:rPr>
-              <a:t>个文件</a:t>
-            </a:r>
-            <a:endParaRPr lang="en-US" sz="3300" b="1">
-              <a:solidFill>
-                <a:srgbClr val="1E4FA8"/>
-              </a:solidFill>
-              <a:latin typeface="微软雅黑" panose="020B0503020204020204" charset="-122"/>
-              <a:ea typeface="微软雅黑" panose="020B0503020204020204" charset="-122"/>
-            </a:endParaRPr>
-          </a:p>
-        </p:txBody>
-      </p:sp>
-      <p:sp>
-        <p:nvSpPr>
-          <p:cNvPr id="93" name="文本框 92" descr="{&quot;isTemplate&quot;:true,&quot;type&quot;:&quot;text&quot;}"/>
+              <a:rPr lang="zh-CN" sz="1650" b="1">
+                <a:solidFill>
+                  <a:srgbClr val="0E3F8C"/>
+                </a:solidFill>
+                <a:latin typeface="微软雅黑" panose="020B0503020204020204" charset="-122"/>
+                <a:ea typeface="微软雅黑" panose="020B0503020204020204" charset="-122"/>
+              </a:rPr>
+              <a:t>开源项目</a:t>
+            </a:r>
+            <a:endParaRPr lang="zh-CN" sz="1650" b="1">
+              <a:solidFill>
+                <a:srgbClr val="0E3F8C"/>
+              </a:solidFill>
+              <a:latin typeface="微软雅黑" panose="020B0503020204020204" charset="-122"/>
+              <a:ea typeface="微软雅黑" panose="020B0503020204020204" charset="-122"/>
+            </a:endParaRPr>
+          </a:p>
+        </p:txBody>
+      </p:sp>
+      <p:sp>
+        <p:nvSpPr>
+          <p:cNvPr id="92" name="文本框 91" descr="{&quot;isTemplate&quot;:true,&quot;type&quot;:&quot;text&quot;}"/>
           <p:cNvSpPr txBox="1"/>
           <p:nvPr>
             <p:custDataLst>
@@ -5045,6 +5957,64 @@
         </p:nvSpPr>
         <p:spPr>
           <a:xfrm>
+            <a:off x="4467225" y="4305300"/>
+            <a:ext cx="3257550" cy="504825"/>
+          </a:xfrm>
+          <a:prstGeom prst="rect">
+            <a:avLst/>
+          </a:prstGeom>
+        </p:spPr>
+        <p:txBody>
+          <a:bodyPr wrap="none" lIns="0" tIns="0" rIns="0" bIns="0"/>
+          <a:p>
+            <a:pPr>
+              <a:lnSpc>
+                <a:spcPct val="100000"/>
+              </a:lnSpc>
+            </a:pPr>
+            <a:r>
+              <a:rPr lang="en-US" altLang="zh-CN" sz="3300" b="1">
+                <a:solidFill>
+                  <a:srgbClr val="1E4FA8"/>
+                </a:solidFill>
+                <a:latin typeface="微软雅黑" panose="020B0503020204020204" charset="-122"/>
+                <a:ea typeface="微软雅黑" panose="020B0503020204020204" charset="-122"/>
+              </a:rPr>
+              <a:t>4</a:t>
+            </a:r>
+            <a:r>
+              <a:rPr lang="zh-CN" altLang="en-US" sz="3300" b="1">
+                <a:solidFill>
+                  <a:srgbClr val="1E4FA8"/>
+                </a:solidFill>
+                <a:latin typeface="微软雅黑" panose="020B0503020204020204" charset="-122"/>
+                <a:ea typeface="微软雅黑" panose="020B0503020204020204" charset="-122"/>
+                <a:cs typeface="Arial" panose="020B0604020202020204" pitchFamily="34" charset="0"/>
+              </a:rPr>
+              <a:t>个文件</a:t>
+            </a:r>
+            <a:endParaRPr lang="en-US" sz="3300" b="1">
+              <a:solidFill>
+                <a:srgbClr val="1E4FA8"/>
+              </a:solidFill>
+              <a:latin typeface="微软雅黑" panose="020B0503020204020204" charset="-122"/>
+              <a:ea typeface="微软雅黑" panose="020B0503020204020204" charset="-122"/>
+            </a:endParaRPr>
+          </a:p>
+        </p:txBody>
+      </p:sp>
+      <p:sp>
+        <p:nvSpPr>
+          <p:cNvPr id="93" name="文本框 92" descr="{&quot;isTemplate&quot;:true,&quot;type&quot;:&quot;text&quot;}"/>
+          <p:cNvSpPr txBox="1"/>
+          <p:nvPr>
+            <p:custDataLst>
+              <p:tags r:id="rId21"/>
+            </p:custDataLst>
+          </p:nvPr>
+        </p:nvSpPr>
+        <p:spPr>
+          <a:xfrm>
             <a:off x="4467225" y="4886325"/>
             <a:ext cx="3317708" cy="409575"/>
           </a:xfrm>
@@ -5167,7 +6137,7 @@
           <p:cNvSpPr/>
           <p:nvPr>
             <p:custDataLst>
-              <p:tags r:id="rId21"/>
+              <p:tags r:id="rId22"/>
             </p:custDataLst>
           </p:nvPr>
         </p:nvSpPr>
@@ -5202,61 +6172,14 @@
           <p:cNvSpPr txBox="1"/>
           <p:nvPr>
             <p:custDataLst>
-              <p:tags r:id="rId22"/>
-            </p:custDataLst>
-          </p:nvPr>
-        </p:nvSpPr>
-        <p:spPr>
-          <a:xfrm>
-            <a:off x="8334375" y="3971925"/>
-            <a:ext cx="3267075" cy="257175"/>
-          </a:xfrm>
-          <a:prstGeom prst="rect">
-            <a:avLst/>
-          </a:prstGeom>
-        </p:spPr>
-        <p:txBody>
-          <a:bodyPr wrap="none" lIns="0" tIns="0" rIns="0" bIns="0"/>
-          <a:p>
-            <a:pPr>
-              <a:lnSpc>
-                <a:spcPct val="100000"/>
-              </a:lnSpc>
-            </a:pPr>
-            <a:r>
-              <a:rPr lang="zh-CN" sz="1650" b="1">
-                <a:solidFill>
-                  <a:srgbClr val="FFFFFF"/>
-                </a:solidFill>
-                <a:latin typeface="微软雅黑" panose="020B0503020204020204" charset="-122"/>
-                <a:ea typeface="微软雅黑" panose="020B0503020204020204" charset="-122"/>
-              </a:rPr>
-              <a:t>论文方法集</a:t>
-            </a:r>
-            <a:endParaRPr lang="zh-CN" sz="1650" b="1">
-              <a:solidFill>
-                <a:srgbClr val="FFFFFF"/>
-              </a:solidFill>
-              <a:latin typeface="微软雅黑" panose="020B0503020204020204" charset="-122"/>
-              <a:ea typeface="微软雅黑" panose="020B0503020204020204" charset="-122"/>
-            </a:endParaRPr>
-          </a:p>
-        </p:txBody>
-      </p:sp>
-      <p:sp>
-        <p:nvSpPr>
-          <p:cNvPr id="96" name="文本框 95" descr="{&quot;isTemplate&quot;:true,&quot;type&quot;:&quot;text&quot;}"/>
-          <p:cNvSpPr txBox="1"/>
-          <p:nvPr>
-            <p:custDataLst>
               <p:tags r:id="rId23"/>
             </p:custDataLst>
           </p:nvPr>
         </p:nvSpPr>
         <p:spPr>
           <a:xfrm>
-            <a:off x="8334375" y="4305300"/>
-            <a:ext cx="3267075" cy="504825"/>
+            <a:off x="8334375" y="3971925"/>
+            <a:ext cx="3267075" cy="257175"/>
           </a:xfrm>
           <a:prstGeom prst="rect">
             <a:avLst/>
@@ -5271,46 +6194,16 @@
               </a:lnSpc>
             </a:pPr>
             <a:r>
-              <a:rPr lang="en-US" sz="3300" b="1">
+              <a:rPr lang="zh-CN" sz="1650" b="1">
                 <a:solidFill>
                   <a:srgbClr val="FFFFFF"/>
                 </a:solidFill>
                 <a:latin typeface="微软雅黑" panose="020B0503020204020204" charset="-122"/>
                 <a:ea typeface="微软雅黑" panose="020B0503020204020204" charset="-122"/>
               </a:rPr>
-              <a:t>4</a:t>
-            </a:r>
-            <a:r>
-              <a:rPr lang="zh-CN" sz="3300" b="1">
-                <a:solidFill>
-                  <a:srgbClr val="FFFFFF"/>
-                </a:solidFill>
-                <a:latin typeface="微软雅黑" panose="020B0503020204020204" charset="-122"/>
-                <a:ea typeface="微软雅黑" panose="020B0503020204020204" charset="-122"/>
-              </a:rPr>
-              <a:t>类</a:t>
-            </a:r>
-            <a:r>
-              <a:rPr lang="en-US" sz="3300" b="1">
-                <a:solidFill>
-                  <a:srgbClr val="FFFFFF"/>
-                </a:solidFill>
-                <a:latin typeface="微软雅黑" panose="020B0503020204020204" charset="-122"/>
-                <a:ea typeface="微软雅黑" panose="020B0503020204020204" charset="-122"/>
-              </a:rPr>
-              <a:t>7</a:t>
-            </a:r>
-            <a:r>
-              <a:rPr lang="zh-CN" sz="3300" b="1">
-                <a:solidFill>
-                  <a:srgbClr val="FFFFFF"/>
-                </a:solidFill>
-                <a:latin typeface="微软雅黑" panose="020B0503020204020204" charset="-122"/>
-                <a:ea typeface="微软雅黑" panose="020B0503020204020204" charset="-122"/>
-              </a:rPr>
-              <a:t>图</a:t>
-            </a:r>
-            <a:endParaRPr lang="zh-CN" sz="3300" b="1">
+              <a:t>开源地址</a:t>
+            </a:r>
+            <a:endParaRPr lang="zh-CN" sz="1650" b="1">
               <a:solidFill>
                 <a:srgbClr val="FFFFFF"/>
               </a:solidFill>
@@ -5332,8 +6225,8 @@
         </p:nvSpPr>
         <p:spPr>
           <a:xfrm>
-            <a:off x="8334375" y="4886325"/>
-            <a:ext cx="3267075" cy="200025"/>
+            <a:off x="8260715" y="4516755"/>
+            <a:ext cx="3288665" cy="504825"/>
           </a:xfrm>
           <a:prstGeom prst="rect">
             <a:avLst/>
@@ -5342,13 +6235,13 @@
         <p:txBody>
           <a:bodyPr wrap="none" lIns="0" tIns="0" rIns="0" bIns="0"/>
           <a:p>
-            <a:pPr>
+            <a:pPr algn="l">
               <a:lnSpc>
                 <a:spcPct val="100000"/>
               </a:lnSpc>
             </a:pPr>
             <a:r>
-              <a:rPr lang="zh-CN" sz="1275">
+              <a:rPr lang="en-US" altLang="zh-CN" sz="1000">
                 <a:solidFill>
                   <a:srgbClr val="FFFFFF">
                     <a:alpha val="85000"/>
@@ -5357,9 +6250,9 @@
                 <a:latin typeface="微软雅黑" panose="020B0503020204020204" charset="-122"/>
                 <a:ea typeface="微软雅黑" panose="020B0503020204020204" charset="-122"/>
               </a:rPr>
-              <a:t>落位总表</a:t>
-            </a:r>
-            <a:endParaRPr lang="zh-CN" sz="1275">
+              <a:t>https://github.com/runlin1113/student_project_II</a:t>
+            </a:r>
+            <a:endParaRPr lang="en-US" altLang="zh-CN" sz="1000">
               <a:solidFill>
                 <a:srgbClr val="FFFFFF">
                   <a:alpha val="85000"/>
@@ -5369,94 +6262,17 @@
               <a:ea typeface="微软雅黑" panose="020B0503020204020204" charset="-122"/>
             </a:endParaRPr>
           </a:p>
-        </p:txBody>
-      </p:sp>
-      <p:sp>
-        <p:nvSpPr>
-          <p:cNvPr id="98" name="文本框 97" descr="{&quot;isTemplate&quot;:true,&quot;type&quot;:&quot;text&quot;}"/>
-          <p:cNvSpPr txBox="1"/>
-          <p:nvPr/>
-        </p:nvSpPr>
-        <p:spPr>
-          <a:xfrm>
-            <a:off x="381000" y="5505450"/>
-            <a:ext cx="11430000" cy="333375"/>
-          </a:xfrm>
-          <a:prstGeom prst="rect">
-            <a:avLst/>
-          </a:prstGeom>
-        </p:spPr>
-        <p:txBody>
-          <a:bodyPr wrap="none" lIns="0" tIns="0" rIns="0" bIns="0"/>
-          <a:p>
-            <a:pPr>
-              <a:lnSpc>
-                <a:spcPct val="160000"/>
-              </a:lnSpc>
-            </a:pPr>
-            <a:r>
-              <a:rPr lang="zh-CN" sz="1350" b="1">
-                <a:solidFill>
-                  <a:srgbClr val="1E4FA8"/>
-                </a:solidFill>
-                <a:latin typeface="微软雅黑" panose="020B0503020204020204" charset="-122"/>
-                <a:ea typeface="微软雅黑" panose="020B0503020204020204" charset="-122"/>
-              </a:rPr>
-              <a:t>所以呢：</a:t>
-            </a:r>
-            <a:r>
-              <a:rPr lang="zh-CN" sz="1350">
-                <a:solidFill>
-                  <a:srgbClr val="1A2230"/>
-                </a:solidFill>
-                <a:latin typeface="微软雅黑" panose="020B0503020204020204" charset="-122"/>
-                <a:ea typeface="微软雅黑" panose="020B0503020204020204" charset="-122"/>
-              </a:rPr>
-              <a:t>这些不是零散笔记，而是可检索、可复用的</a:t>
-            </a:r>
-            <a:r>
-              <a:rPr lang="en-US" sz="1350">
-                <a:solidFill>
-                  <a:srgbClr val="1A2230"/>
-                </a:solidFill>
-                <a:latin typeface="微软雅黑" panose="020B0503020204020204" charset="-122"/>
-                <a:ea typeface="微软雅黑" panose="020B0503020204020204" charset="-122"/>
-              </a:rPr>
-              <a:t>"</a:t>
-            </a:r>
-            <a:r>
-              <a:rPr lang="zh-CN" sz="1350">
-                <a:solidFill>
-                  <a:srgbClr val="1A2230"/>
-                </a:solidFill>
-                <a:latin typeface="微软雅黑" panose="020B0503020204020204" charset="-122"/>
-                <a:ea typeface="微软雅黑" panose="020B0503020204020204" charset="-122"/>
-              </a:rPr>
-              <a:t>方法论文献底座</a:t>
-            </a:r>
-            <a:r>
-              <a:rPr lang="en-US" sz="1350">
-                <a:solidFill>
-                  <a:srgbClr val="1A2230"/>
-                </a:solidFill>
-                <a:latin typeface="微软雅黑" panose="020B0503020204020204" charset="-122"/>
-                <a:ea typeface="微软雅黑" panose="020B0503020204020204" charset="-122"/>
-              </a:rPr>
-              <a:t>"——</a:t>
-            </a:r>
-            <a:r>
-              <a:rPr lang="zh-CN" sz="1350">
-                <a:solidFill>
-                  <a:srgbClr val="1A2230"/>
-                </a:solidFill>
-                <a:latin typeface="微软雅黑" panose="020B0503020204020204" charset="-122"/>
-                <a:ea typeface="微软雅黑" panose="020B0503020204020204" charset="-122"/>
-              </a:rPr>
-              <a:t>后续实验直接调用，不必从头调研。</a:t>
-            </a:r>
-            <a:endParaRPr lang="zh-CN" sz="1350">
-              <a:solidFill>
-                <a:srgbClr val="1A2230"/>
+          <a:p>
+            <a:pPr algn="l">
+              <a:lnSpc>
+                <a:spcPct val="100000"/>
+              </a:lnSpc>
+            </a:pPr>
+            <a:endParaRPr lang="en-US" altLang="zh-CN" sz="1000">
+              <a:solidFill>
+                <a:srgbClr val="FFFFFF">
+                  <a:alpha val="85000"/>
+                </a:srgbClr>
               </a:solidFill>
               <a:latin typeface="微软雅黑" panose="020B0503020204020204" charset="-122"/>
               <a:ea typeface="微软雅黑" panose="020B0503020204020204" charset="-122"/>
@@ -5626,6 +6442,122 @@
               </a:solidFill>
               <a:latin typeface="微软雅黑" panose="020B0503020204020204" charset="-122"/>
               <a:ea typeface="微软雅黑" panose="020B0503020204020204" charset="-122"/>
+            </a:endParaRPr>
+          </a:p>
+        </p:txBody>
+      </p:sp>
+      <p:sp>
+        <p:nvSpPr>
+          <p:cNvPr id="1" name="文本框 0"/>
+          <p:cNvSpPr txBox="1"/>
+          <p:nvPr/>
+        </p:nvSpPr>
+        <p:spPr>
+          <a:xfrm>
+            <a:off x="381000" y="6233160"/>
+            <a:ext cx="11430000" cy="453390"/>
+          </a:xfrm>
+          <a:prstGeom prst="rect">
+            <a:avLst/>
+          </a:prstGeom>
+        </p:spPr>
+        <p:txBody>
+          <a:bodyPr>
+            <a:noAutofit/>
+            <a:extLst>
+              <a:ext uri="{4A0BC546-FE56-4ADE-93B0-CB8AF2F6F144}">
+                <wpsdc:textFrameExt xmlns:wpsdc="http://www.wps.cn/officeDocument/2022/drawingmlCustomData" type="text"/>
+              </a:ext>
+            </a:extLst>
+          </a:bodyPr>
+          <a:p>
+            <a:pPr algn="l"/>
+            <a:r>
+              <a:rPr lang="zh-CN" altLang="en-US" sz="1000">
+                <a:latin typeface="Arial" panose="020B0604020202020204" pitchFamily="34" charset="0"/>
+                <a:ea typeface="微软雅黑" panose="020B0503020204020204" charset="-122"/>
+              </a:rPr>
+              <a:t>参考文献：</a:t>
+            </a:r>
+            <a:endParaRPr lang="en-US" altLang="zh-CN" sz="1000">
+              <a:latin typeface="Arial" panose="020B0604020202020204" pitchFamily="34" charset="0"/>
+              <a:ea typeface="微软雅黑" panose="020B0503020204020204" charset="-122"/>
+            </a:endParaRPr>
+          </a:p>
+          <a:p>
+            <a:pPr algn="l"/>
+            <a:r>
+              <a:rPr lang="en-US" altLang="zh-CN" sz="1000">
+                <a:latin typeface="Arial" panose="020B0604020202020204" pitchFamily="34" charset="0"/>
+                <a:ea typeface="微软雅黑" panose="020B0503020204020204" charset="-122"/>
+              </a:rPr>
+              <a:t>YAO S, SHINN N, RAZAVI P, et al. τ-bench: A Benchmark for Tool-Agent-User Interaction in Real-World Domains[R/OL]. arXiv preprint, 2024. arXiv:2406.12045.</a:t>
+            </a:r>
+            <a:endParaRPr lang="en-US" altLang="zh-CN" sz="1000">
+              <a:latin typeface="Arial" panose="020B0604020202020204" pitchFamily="34" charset="0"/>
+              <a:ea typeface="微软雅黑" panose="020B0503020204020204" charset="-122"/>
+            </a:endParaRPr>
+          </a:p>
+          <a:p>
+            <a:pPr algn="l"/>
+            <a:r>
+              <a:rPr lang="en-US" altLang="zh-CN" sz="1000">
+                <a:latin typeface="Arial" panose="020B0604020202020204" pitchFamily="34" charset="0"/>
+                <a:ea typeface="微软雅黑" panose="020B0503020204020204" charset="-122"/>
+              </a:rPr>
+              <a:t>BHATNAGAR A, YANG Z, MCCLURE S, et al. Automated Synthesis of Cloud Emulators[R/OL]. arXiv preprint, 2026. arXiv:2608.23842.</a:t>
+            </a:r>
+            <a:endParaRPr lang="en-US" altLang="zh-CN" sz="1000">
+              <a:latin typeface="Arial" panose="020B0604020202020204" pitchFamily="34" charset="0"/>
+              <a:ea typeface="微软雅黑" panose="020B0503020204020204" charset="-122"/>
+            </a:endParaRPr>
+          </a:p>
+        </p:txBody>
+      </p:sp>
+      <p:sp>
+        <p:nvSpPr>
+          <p:cNvPr id="2" name="文本框 1"/>
+          <p:cNvSpPr txBox="1"/>
+          <p:nvPr/>
+        </p:nvSpPr>
+        <p:spPr>
+          <a:xfrm>
+            <a:off x="467360" y="5857790"/>
+            <a:ext cx="4064000" cy="368300"/>
+          </a:xfrm>
+          <a:prstGeom prst="rect">
+            <a:avLst/>
+          </a:prstGeom>
+        </p:spPr>
+        <p:txBody>
+          <a:bodyPr>
+            <a:spAutoFit/>
+            <a:extLst>
+              <a:ext uri="{4A0BC546-FE56-4ADE-93B0-CB8AF2F6F144}">
+                <wpsdc:textFrameExt xmlns:wpsdc="http://www.wps.cn/officeDocument/2022/drawingmlCustomData" type="text"/>
+              </a:ext>
+            </a:extLst>
+          </a:bodyPr>
+          <a:p>
+            <a:pPr algn="l"/>
+            <a:r>
+              <a:rPr lang="zh-CN" altLang="en-US" sz="1800">
+                <a:solidFill>
+                  <a:schemeClr val="bg1"/>
+                </a:solidFill>
+                <a:latin typeface="Arial" panose="020B0604020202020204" pitchFamily="34" charset="0"/>
+                <a:ea typeface="微软雅黑" panose="020B0503020204020204" charset="-122"/>
+                <a:hlinkClick r:id="rId1" tooltip="" action="ppaction://hlinkfile"/>
+              </a:rPr>
+              <a:t>调研结果网页</a:t>
+            </a:r>
+            <a:endParaRPr lang="zh-CN" altLang="en-US" sz="1800">
+              <a:solidFill>
+                <a:schemeClr val="bg1"/>
+              </a:solidFill>
+              <a:latin typeface="Arial" panose="020B0604020202020204" pitchFamily="34" charset="0"/>
+              <a:ea typeface="微软雅黑" panose="020B0503020204020204" charset="-122"/>
+              <a:hlinkClick r:id="rId1" tooltip="" action="ppaction://hlinkfile"/>
             </a:endParaRPr>
           </a:p>
         </p:txBody>
@@ -5638,7 +6570,7 @@
 </p:sld>
 </file>
 
-<file path=ppt/slides/slide6.xml><?xml version="1.0" encoding="utf-8"?>
+<file path=ppt/slides/slide7.xml><?xml version="1.0" encoding="utf-8"?>
 <p:sld xmlns:a="http://schemas.openxmlformats.org/drawingml/2006/main" xmlns:r="http://schemas.openxmlformats.org/officeDocument/2006/relationships" xmlns:p="http://schemas.openxmlformats.org/presentationml/2006/main">
   <p:cSld>
     <p:spTree>
@@ -6510,91 +7442,91 @@
 
 <file path=ppt/tags/tag1.xml><?xml version="1.0" encoding="utf-8"?>
 <p:tagLst xmlns:p="http://schemas.openxmlformats.org/presentationml/2006/main">
-  <p:tag name="KSO_WM_DIAGRAM_VIRTUALLY_FRAME" val="{&quot;height&quot;:258,&quot;left&quot;:30,&quot;top&quot;:159,&quot;width&quot;:900}"/>
+  <p:tag name="KSO_WM_DIAGRAM_VIRTUALLY_FRAME" val="{&quot;height&quot;:288,&quot;left&quot;:382.5,&quot;top&quot;:159,&quot;width&quot;:541.5}"/>
 </p:tagLst>
 </file>
 
 <file path=ppt/tags/tag10.xml><?xml version="1.0" encoding="utf-8"?>
 <p:tagLst xmlns:p="http://schemas.openxmlformats.org/presentationml/2006/main">
-  <p:tag name="KSO_WM_DIAGRAM_VIRTUALLY_FRAME" val="{&quot;height&quot;:258,&quot;left&quot;:30,&quot;top&quot;:159,&quot;width&quot;:900}"/>
+  <p:tag name="KSO_WM_DIAGRAM_VIRTUALLY_FRAME" val="{&quot;height&quot;:416.25,&quot;left&quot;:13.302598425196852,&quot;top&quot;:81,&quot;width&quot;:916.6974015748032}"/>
 </p:tagLst>
 </file>
 
 <file path=ppt/tags/tag11.xml><?xml version="1.0" encoding="utf-8"?>
 <p:tagLst xmlns:p="http://schemas.openxmlformats.org/presentationml/2006/main">
-  <p:tag name="KSO_WM_DIAGRAM_VIRTUALLY_FRAME" val="{&quot;height&quot;:258,&quot;left&quot;:30,&quot;top&quot;:159,&quot;width&quot;:900}"/>
+  <p:tag name="KSO_WM_DIAGRAM_VIRTUALLY_FRAME" val="{&quot;height&quot;:416.25,&quot;left&quot;:13.302598425196852,&quot;top&quot;:81,&quot;width&quot;:916.6974015748032}"/>
 </p:tagLst>
 </file>
 
 <file path=ppt/tags/tag12.xml><?xml version="1.0" encoding="utf-8"?>
 <p:tagLst xmlns:p="http://schemas.openxmlformats.org/presentationml/2006/main">
-  <p:tag name="KSO_WM_DIAGRAM_VIRTUALLY_FRAME" val="{&quot;height&quot;:258,&quot;left&quot;:30,&quot;top&quot;:159,&quot;width&quot;:900}"/>
+  <p:tag name="KSO_WM_DIAGRAM_VIRTUALLY_FRAME" val="{&quot;height&quot;:416.25,&quot;left&quot;:13.302598425196852,&quot;top&quot;:81,&quot;width&quot;:916.6974015748032}"/>
 </p:tagLst>
 </file>
 
 <file path=ppt/tags/tag13.xml><?xml version="1.0" encoding="utf-8"?>
 <p:tagLst xmlns:p="http://schemas.openxmlformats.org/presentationml/2006/main">
-  <p:tag name="KSO_WM_DIAGRAM_VIRTUALLY_FRAME" val="{&quot;height&quot;:258,&quot;left&quot;:30,&quot;top&quot;:159,&quot;width&quot;:900}"/>
+  <p:tag name="KSO_WM_DIAGRAM_VIRTUALLY_FRAME" val="{&quot;height&quot;:416.25,&quot;left&quot;:13.302598425196852,&quot;top&quot;:81,&quot;width&quot;:916.6974015748032}"/>
 </p:tagLst>
 </file>
 
 <file path=ppt/tags/tag14.xml><?xml version="1.0" encoding="utf-8"?>
 <p:tagLst xmlns:p="http://schemas.openxmlformats.org/presentationml/2006/main">
-  <p:tag name="KSO_WM_DIAGRAM_VIRTUALLY_FRAME" val="{&quot;height&quot;:258,&quot;left&quot;:30,&quot;top&quot;:159,&quot;width&quot;:900}"/>
+  <p:tag name="KSO_WM_DIAGRAM_VIRTUALLY_FRAME" val="{&quot;height&quot;:416.25,&quot;left&quot;:13.302598425196852,&quot;top&quot;:81,&quot;width&quot;:916.6974015748032}"/>
 </p:tagLst>
 </file>
 
 <file path=ppt/tags/tag15.xml><?xml version="1.0" encoding="utf-8"?>
 <p:tagLst xmlns:p="http://schemas.openxmlformats.org/presentationml/2006/main">
-  <p:tag name="KSO_WM_DIAGRAM_VIRTUALLY_FRAME" val="{&quot;height&quot;:258,&quot;left&quot;:30,&quot;top&quot;:159,&quot;width&quot;:900}"/>
+  <p:tag name="KSO_WM_DIAGRAM_VIRTUALLY_FRAME" val="{&quot;height&quot;:416.25,&quot;left&quot;:13.302598425196852,&quot;top&quot;:81,&quot;width&quot;:916.6974015748032}"/>
 </p:tagLst>
 </file>
 
 <file path=ppt/tags/tag16.xml><?xml version="1.0" encoding="utf-8"?>
 <p:tagLst xmlns:p="http://schemas.openxmlformats.org/presentationml/2006/main">
-  <p:tag name="KSO_WM_DIAGRAM_VIRTUALLY_FRAME" val="{&quot;height&quot;:258,&quot;left&quot;:30,&quot;top&quot;:159,&quot;width&quot;:900}"/>
+  <p:tag name="KSO_WM_DIAGRAM_VIRTUALLY_FRAME" val="{&quot;height&quot;:416.25,&quot;left&quot;:13.302598425196852,&quot;top&quot;:81,&quot;width&quot;:916.6974015748032}"/>
 </p:tagLst>
 </file>
 
 <file path=ppt/tags/tag17.xml><?xml version="1.0" encoding="utf-8"?>
 <p:tagLst xmlns:p="http://schemas.openxmlformats.org/presentationml/2006/main">
-  <p:tag name="KSO_WM_DIAGRAM_VIRTUALLY_FRAME" val="{&quot;height&quot;:258,&quot;left&quot;:30,&quot;top&quot;:159,&quot;width&quot;:900}"/>
+  <p:tag name="KSO_WM_DIAGRAM_VIRTUALLY_FRAME" val="{&quot;height&quot;:416.25,&quot;left&quot;:13.302598425196852,&quot;top&quot;:81,&quot;width&quot;:916.6974015748032}"/>
 </p:tagLst>
 </file>
 
 <file path=ppt/tags/tag18.xml><?xml version="1.0" encoding="utf-8"?>
 <p:tagLst xmlns:p="http://schemas.openxmlformats.org/presentationml/2006/main">
-  <p:tag name="KSO_WM_DIAGRAM_VIRTUALLY_FRAME" val="{&quot;height&quot;:258,&quot;left&quot;:30,&quot;top&quot;:159,&quot;width&quot;:900}"/>
+  <p:tag name="KSO_WM_DIAGRAM_VIRTUALLY_FRAME" val="{&quot;height&quot;:416.25,&quot;left&quot;:13.302598425196852,&quot;top&quot;:81,&quot;width&quot;:916.6974015748032}"/>
 </p:tagLst>
 </file>
 
 <file path=ppt/tags/tag19.xml><?xml version="1.0" encoding="utf-8"?>
 <p:tagLst xmlns:p="http://schemas.openxmlformats.org/presentationml/2006/main">
-  <p:tag name="KSO_WM_DIAGRAM_VIRTUALLY_FRAME" val="{&quot;height&quot;:258,&quot;left&quot;:30,&quot;top&quot;:159,&quot;width&quot;:900}"/>
+  <p:tag name="KSO_WM_DIAGRAM_VIRTUALLY_FRAME" val="{&quot;height&quot;:416.25,&quot;left&quot;:13.302598425196852,&quot;top&quot;:81,&quot;width&quot;:916.6974015748032}"/>
 </p:tagLst>
 </file>
 
 <file path=ppt/tags/tag2.xml><?xml version="1.0" encoding="utf-8"?>
 <p:tagLst xmlns:p="http://schemas.openxmlformats.org/presentationml/2006/main">
-  <p:tag name="KSO_WM_DIAGRAM_VIRTUALLY_FRAME" val="{&quot;height&quot;:258,&quot;left&quot;:30,&quot;top&quot;:159,&quot;width&quot;:900}"/>
+  <p:tag name="KSO_WM_DIAGRAM_VIRTUALLY_FRAME" val="{&quot;height&quot;:288,&quot;left&quot;:382.5,&quot;top&quot;:159,&quot;width&quot;:541.5}"/>
 </p:tagLst>
 </file>
 
 <file path=ppt/tags/tag20.xml><?xml version="1.0" encoding="utf-8"?>
 <p:tagLst xmlns:p="http://schemas.openxmlformats.org/presentationml/2006/main">
-  <p:tag name="KSO_WM_DIAGRAM_VIRTUALLY_FRAME" val="{&quot;height&quot;:258,&quot;left&quot;:30,&quot;top&quot;:159,&quot;width&quot;:900}"/>
+  <p:tag name="KSO_WM_DIAGRAM_VIRTUALLY_FRAME" val="{&quot;height&quot;:416.25,&quot;left&quot;:13.302598425196852,&quot;top&quot;:81,&quot;width&quot;:916.6974015748032}"/>
 </p:tagLst>
 </file>
 
 <file path=ppt/tags/tag21.xml><?xml version="1.0" encoding="utf-8"?>
 <p:tagLst xmlns:p="http://schemas.openxmlformats.org/presentationml/2006/main">
-  <p:tag name="KSO_WM_DIAGRAM_VIRTUALLY_FRAME" val="{&quot;height&quot;:258,&quot;left&quot;:30,&quot;top&quot;:159,&quot;width&quot;:900}"/>
+  <p:tag name="KSO_WM_DIAGRAM_VIRTUALLY_FRAME" val="{&quot;height&quot;:416.25,&quot;left&quot;:13.302598425196852,&quot;top&quot;:81,&quot;width&quot;:916.6974015748032}"/>
 </p:tagLst>
 </file>
 
 <file path=ppt/tags/tag22.xml><?xml version="1.0" encoding="utf-8"?>
 <p:tagLst xmlns:p="http://schemas.openxmlformats.org/presentationml/2006/main">
-  <p:tag name="KSO_WM_DIAGRAM_VIRTUALLY_FRAME" val="{&quot;height&quot;:258,&quot;left&quot;:30,&quot;top&quot;:159,&quot;width&quot;:900}"/>
+  <p:tag name="KSO_WM_DIAGRAM_VIRTUALLY_FRAME" val="{&quot;height&quot;:416.25,&quot;left&quot;:13.302598425196852,&quot;top&quot;:81,&quot;width&quot;:916.6974015748032}"/>
 </p:tagLst>
 </file>
 
@@ -6618,11 +7550,23 @@
 
 <file path=ppt/tags/tag26.xml><?xml version="1.0" encoding="utf-8"?>
 <p:tagLst xmlns:p="http://schemas.openxmlformats.org/presentationml/2006/main">
-  <p:tag name="KSO_WM_DIAGRAM_VIRTUALLY_FRAME" val="{&quot;height&quot;:258,&quot;left&quot;:30,&quot;top&quot;:159,&quot;width&quot;:900}"/>
+  <p:tag name="KSO_WM_DIAGRAM_VIRTUALLY_FRAME" val="{&quot;height&quot;:416.25,&quot;left&quot;:13.302598425196852,&quot;top&quot;:81,&quot;width&quot;:916.6974015748032}"/>
 </p:tagLst>
 </file>
 
 <file path=ppt/tags/tag27.xml><?xml version="1.0" encoding="utf-8"?>
+<p:tagLst xmlns:p="http://schemas.openxmlformats.org/presentationml/2006/main">
+  <p:tag name="KSO_WM_DIAGRAM_VIRTUALLY_FRAME" val="{&quot;height&quot;:416.25,&quot;left&quot;:13.302598425196852,&quot;top&quot;:81,&quot;width&quot;:916.6974015748032}"/>
+</p:tagLst>
+</file>
+
+<file path=ppt/tags/tag28.xml><?xml version="1.0" encoding="utf-8"?>
+<p:tagLst xmlns:p="http://schemas.openxmlformats.org/presentationml/2006/main">
+  <p:tag name="KSO_WM_DIAGRAM_VIRTUALLY_FRAME" val="{&quot;height&quot;:288,&quot;left&quot;:382.5,&quot;top&quot;:159,&quot;width&quot;:541.5}"/>
+</p:tagLst>
+</file>
+
+<file path=ppt/tags/tag29.xml><?xml version="1.0" encoding="utf-8"?>
 <p:tagLst xmlns:p="http://schemas.openxmlformats.org/presentationml/2006/main">
   <p:tag name="KSO_WM_DIAGRAM_VIRTUALLY_FRAME" val="{&quot;height&quot;:258,&quot;left&quot;:30,&quot;top&quot;:159,&quot;width&quot;:900}"/>
 </p:tagLst>
@@ -6630,11 +7574,131 @@
 
 <file path=ppt/tags/tag3.xml><?xml version="1.0" encoding="utf-8"?>
 <p:tagLst xmlns:p="http://schemas.openxmlformats.org/presentationml/2006/main">
+  <p:tag name="KSO_WM_DIAGRAM_VIRTUALLY_FRAME" val="{&quot;height&quot;:288,&quot;left&quot;:382.5,&quot;top&quot;:159,&quot;width&quot;:541.5}"/>
+</p:tagLst>
+</file>
+
+<file path=ppt/tags/tag30.xml><?xml version="1.0" encoding="utf-8"?>
+<p:tagLst xmlns:p="http://schemas.openxmlformats.org/presentationml/2006/main">
+  <p:tag name="KSO_WM_DIAGRAM_VIRTUALLY_FRAME" val="{&quot;height&quot;:258,&quot;left&quot;:30,&quot;top&quot;:159,&quot;width&quot;:900}"/>
+</p:tagLst>
+</file>
+
+<file path=ppt/tags/tag31.xml><?xml version="1.0" encoding="utf-8"?>
+<p:tagLst xmlns:p="http://schemas.openxmlformats.org/presentationml/2006/main">
+  <p:tag name="KSO_WM_DIAGRAM_VIRTUALLY_FRAME" val="{&quot;height&quot;:258,&quot;left&quot;:30,&quot;top&quot;:159,&quot;width&quot;:900}"/>
+</p:tagLst>
+</file>
+
+<file path=ppt/tags/tag32.xml><?xml version="1.0" encoding="utf-8"?>
+<p:tagLst xmlns:p="http://schemas.openxmlformats.org/presentationml/2006/main">
+  <p:tag name="KSO_WM_DIAGRAM_VIRTUALLY_FRAME" val="{&quot;height&quot;:258,&quot;left&quot;:30,&quot;top&quot;:159,&quot;width&quot;:900}"/>
+</p:tagLst>
+</file>
+
+<file path=ppt/tags/tag33.xml><?xml version="1.0" encoding="utf-8"?>
+<p:tagLst xmlns:p="http://schemas.openxmlformats.org/presentationml/2006/main">
+  <p:tag name="KSO_WM_DIAGRAM_VIRTUALLY_FRAME" val="{&quot;height&quot;:258,&quot;left&quot;:30,&quot;top&quot;:159,&quot;width&quot;:900}"/>
+</p:tagLst>
+</file>
+
+<file path=ppt/tags/tag34.xml><?xml version="1.0" encoding="utf-8"?>
+<p:tagLst xmlns:p="http://schemas.openxmlformats.org/presentationml/2006/main">
+  <p:tag name="KSO_WM_DIAGRAM_VIRTUALLY_FRAME" val="{&quot;height&quot;:258,&quot;left&quot;:30,&quot;top&quot;:159,&quot;width&quot;:900}"/>
+</p:tagLst>
+</file>
+
+<file path=ppt/tags/tag35.xml><?xml version="1.0" encoding="utf-8"?>
+<p:tagLst xmlns:p="http://schemas.openxmlformats.org/presentationml/2006/main">
+  <p:tag name="KSO_WM_DIAGRAM_VIRTUALLY_FRAME" val="{&quot;height&quot;:258,&quot;left&quot;:30,&quot;top&quot;:159,&quot;width&quot;:900}"/>
+</p:tagLst>
+</file>
+
+<file path=ppt/tags/tag36.xml><?xml version="1.0" encoding="utf-8"?>
+<p:tagLst xmlns:p="http://schemas.openxmlformats.org/presentationml/2006/main">
+  <p:tag name="KSO_WM_DIAGRAM_VIRTUALLY_FRAME" val="{&quot;height&quot;:258,&quot;left&quot;:30,&quot;top&quot;:159,&quot;width&quot;:900}"/>
+</p:tagLst>
+</file>
+
+<file path=ppt/tags/tag37.xml><?xml version="1.0" encoding="utf-8"?>
+<p:tagLst xmlns:p="http://schemas.openxmlformats.org/presentationml/2006/main">
+  <p:tag name="KSO_WM_DIAGRAM_VIRTUALLY_FRAME" val="{&quot;height&quot;:258,&quot;left&quot;:30,&quot;top&quot;:159,&quot;width&quot;:900}"/>
+</p:tagLst>
+</file>
+
+<file path=ppt/tags/tag38.xml><?xml version="1.0" encoding="utf-8"?>
+<p:tagLst xmlns:p="http://schemas.openxmlformats.org/presentationml/2006/main">
+  <p:tag name="KSO_WM_DIAGRAM_VIRTUALLY_FRAME" val="{&quot;height&quot;:258,&quot;left&quot;:30,&quot;top&quot;:159,&quot;width&quot;:900}"/>
+</p:tagLst>
+</file>
+
+<file path=ppt/tags/tag39.xml><?xml version="1.0" encoding="utf-8"?>
+<p:tagLst xmlns:p="http://schemas.openxmlformats.org/presentationml/2006/main">
   <p:tag name="KSO_WM_DIAGRAM_VIRTUALLY_FRAME" val="{&quot;height&quot;:258,&quot;left&quot;:30,&quot;top&quot;:159,&quot;width&quot;:900}"/>
 </p:tagLst>
 </file>
 
 <file path=ppt/tags/tag4.xml><?xml version="1.0" encoding="utf-8"?>
+<p:tagLst xmlns:p="http://schemas.openxmlformats.org/presentationml/2006/main">
+  <p:tag name="KSO_WM_DIAGRAM_VIRTUALLY_FRAME" val="{&quot;height&quot;:288,&quot;left&quot;:382.5,&quot;top&quot;:159,&quot;width&quot;:541.5}"/>
+</p:tagLst>
+</file>
+
+<file path=ppt/tags/tag40.xml><?xml version="1.0" encoding="utf-8"?>
+<p:tagLst xmlns:p="http://schemas.openxmlformats.org/presentationml/2006/main">
+  <p:tag name="KSO_WM_DIAGRAM_VIRTUALLY_FRAME" val="{&quot;height&quot;:258,&quot;left&quot;:30,&quot;top&quot;:159,&quot;width&quot;:900}"/>
+</p:tagLst>
+</file>
+
+<file path=ppt/tags/tag41.xml><?xml version="1.0" encoding="utf-8"?>
+<p:tagLst xmlns:p="http://schemas.openxmlformats.org/presentationml/2006/main">
+  <p:tag name="KSO_WM_DIAGRAM_VIRTUALLY_FRAME" val="{&quot;height&quot;:258,&quot;left&quot;:30,&quot;top&quot;:159,&quot;width&quot;:900}"/>
+</p:tagLst>
+</file>
+
+<file path=ppt/tags/tag42.xml><?xml version="1.0" encoding="utf-8"?>
+<p:tagLst xmlns:p="http://schemas.openxmlformats.org/presentationml/2006/main">
+  <p:tag name="KSO_WM_DIAGRAM_VIRTUALLY_FRAME" val="{&quot;height&quot;:258,&quot;left&quot;:30,&quot;top&quot;:159,&quot;width&quot;:900}"/>
+</p:tagLst>
+</file>
+
+<file path=ppt/tags/tag43.xml><?xml version="1.0" encoding="utf-8"?>
+<p:tagLst xmlns:p="http://schemas.openxmlformats.org/presentationml/2006/main">
+  <p:tag name="KSO_WM_DIAGRAM_VIRTUALLY_FRAME" val="{&quot;height&quot;:258,&quot;left&quot;:30,&quot;top&quot;:159,&quot;width&quot;:900}"/>
+</p:tagLst>
+</file>
+
+<file path=ppt/tags/tag44.xml><?xml version="1.0" encoding="utf-8"?>
+<p:tagLst xmlns:p="http://schemas.openxmlformats.org/presentationml/2006/main">
+  <p:tag name="KSO_WM_DIAGRAM_VIRTUALLY_FRAME" val="{&quot;height&quot;:258,&quot;left&quot;:30,&quot;top&quot;:159,&quot;width&quot;:900}"/>
+</p:tagLst>
+</file>
+
+<file path=ppt/tags/tag45.xml><?xml version="1.0" encoding="utf-8"?>
+<p:tagLst xmlns:p="http://schemas.openxmlformats.org/presentationml/2006/main">
+  <p:tag name="KSO_WM_DIAGRAM_VIRTUALLY_FRAME" val="{&quot;height&quot;:258,&quot;left&quot;:30,&quot;top&quot;:159,&quot;width&quot;:900}"/>
+</p:tagLst>
+</file>
+
+<file path=ppt/tags/tag46.xml><?xml version="1.0" encoding="utf-8"?>
+<p:tagLst xmlns:p="http://schemas.openxmlformats.org/presentationml/2006/main">
+  <p:tag name="KSO_WM_DIAGRAM_VIRTUALLY_FRAME" val="{&quot;height&quot;:258,&quot;left&quot;:30,&quot;top&quot;:159,&quot;width&quot;:900}"/>
+</p:tagLst>
+</file>
+
+<file path=ppt/tags/tag47.xml><?xml version="1.0" encoding="utf-8"?>
+<p:tagLst xmlns:p="http://schemas.openxmlformats.org/presentationml/2006/main">
+  <p:tag name="KSO_WM_DIAGRAM_VIRTUALLY_FRAME" val="{&quot;height&quot;:258,&quot;left&quot;:30,&quot;top&quot;:159,&quot;width&quot;:900}"/>
+</p:tagLst>
+</file>
+
+<file path=ppt/tags/tag48.xml><?xml version="1.0" encoding="utf-8"?>
+<p:tagLst xmlns:p="http://schemas.openxmlformats.org/presentationml/2006/main">
+  <p:tag name="KSO_WM_DIAGRAM_VIRTUALLY_FRAME" val="{&quot;height&quot;:258,&quot;left&quot;:30,&quot;top&quot;:159,&quot;width&quot;:900}"/>
+</p:tagLst>
+</file>
+
+<file path=ppt/tags/tag49.xml><?xml version="1.0" encoding="utf-8"?>
 <p:tagLst xmlns:p="http://schemas.openxmlformats.org/presentationml/2006/main">
   <p:tag name="KSO_WM_DIAGRAM_VIRTUALLY_FRAME" val="{&quot;height&quot;:258,&quot;left&quot;:30,&quot;top&quot;:159,&quot;width&quot;:900}"/>
 </p:tagLst>
@@ -6642,31 +7706,43 @@
 
 <file path=ppt/tags/tag5.xml><?xml version="1.0" encoding="utf-8"?>
 <p:tagLst xmlns:p="http://schemas.openxmlformats.org/presentationml/2006/main">
+  <p:tag name="KSO_WM_DIAGRAM_VIRTUALLY_FRAME" val="{&quot;height&quot;:288,&quot;left&quot;:382.5,&quot;top&quot;:159,&quot;width&quot;:541.5}"/>
+</p:tagLst>
+</file>
+
+<file path=ppt/tags/tag50.xml><?xml version="1.0" encoding="utf-8"?>
+<p:tagLst xmlns:p="http://schemas.openxmlformats.org/presentationml/2006/main">
+  <p:tag name="KSO_WM_DIAGRAM_VIRTUALLY_FRAME" val="{&quot;height&quot;:258,&quot;left&quot;:30,&quot;top&quot;:159,&quot;width&quot;:900}"/>
+</p:tagLst>
+</file>
+
+<file path=ppt/tags/tag51.xml><?xml version="1.0" encoding="utf-8"?>
+<p:tagLst xmlns:p="http://schemas.openxmlformats.org/presentationml/2006/main">
   <p:tag name="KSO_WM_DIAGRAM_VIRTUALLY_FRAME" val="{&quot;height&quot;:258,&quot;left&quot;:30,&quot;top&quot;:159,&quot;width&quot;:900}"/>
 </p:tagLst>
 </file>
 
 <file path=ppt/tags/tag6.xml><?xml version="1.0" encoding="utf-8"?>
 <p:tagLst xmlns:p="http://schemas.openxmlformats.org/presentationml/2006/main">
-  <p:tag name="KSO_WM_DIAGRAM_VIRTUALLY_FRAME" val="{&quot;height&quot;:258,&quot;left&quot;:30,&quot;top&quot;:159,&quot;width&quot;:900}"/>
+  <p:tag name="KSO_WM_DIAGRAM_VIRTUALLY_FRAME" val="{&quot;height&quot;:288,&quot;left&quot;:382.5,&quot;top&quot;:159,&quot;width&quot;:541.5}"/>
 </p:tagLst>
 </file>
 
 <file path=ppt/tags/tag7.xml><?xml version="1.0" encoding="utf-8"?>
 <p:tagLst xmlns:p="http://schemas.openxmlformats.org/presentationml/2006/main">
-  <p:tag name="KSO_WM_DIAGRAM_VIRTUALLY_FRAME" val="{&quot;height&quot;:258,&quot;left&quot;:30,&quot;top&quot;:159,&quot;width&quot;:900}"/>
+  <p:tag name="KSO_WM_DIAGRAM_VIRTUALLY_FRAME" val="{&quot;height&quot;:288,&quot;left&quot;:382.5,&quot;top&quot;:159,&quot;width&quot;:541.5}"/>
 </p:tagLst>
 </file>
 
 <file path=ppt/tags/tag8.xml><?xml version="1.0" encoding="utf-8"?>
 <p:tagLst xmlns:p="http://schemas.openxmlformats.org/presentationml/2006/main">
-  <p:tag name="KSO_WM_DIAGRAM_VIRTUALLY_FRAME" val="{&quot;height&quot;:258,&quot;left&quot;:30,&quot;top&quot;:159,&quot;width&quot;:900}"/>
+  <p:tag name="KSO_WM_DIAGRAM_VIRTUALLY_FRAME" val="{&quot;height&quot;:288,&quot;left&quot;:382.5,&quot;top&quot;:159,&quot;width&quot;:541.5}"/>
 </p:tagLst>
 </file>
 
 <file path=ppt/tags/tag9.xml><?xml version="1.0" encoding="utf-8"?>
 <p:tagLst xmlns:p="http://schemas.openxmlformats.org/presentationml/2006/main">
-  <p:tag name="KSO_WM_DIAGRAM_VIRTUALLY_FRAME" val="{&quot;height&quot;:258,&quot;left&quot;:30,&quot;top&quot;:159,&quot;width&quot;:900}"/>
+  <p:tag name="KSO_WM_DIAGRAM_VIRTUALLY_FRAME" val="{&quot;height&quot;:288,&quot;left&quot;:382.5,&quot;top&quot;:159,&quot;width&quot;:541.5}"/>
 </p:tagLst>
 </file>
 

</xml_diff>